<commit_message>
docs: add copyright to MVP evidence media
</commit_message>
<xml_diff>
--- a/site/media/mvp-evidence-v2/aws-public-change-alerting-mvp-evidence-v2.pptx
+++ b/site/media/mvp-evidence-v2/aws-public-change-alerting-mvp-evidence-v2.pptx
@@ -2,21 +2,21 @@
 <file path=ppt/presentation.xml><?xml version="1.0" encoding="utf-8"?>
 <p:presentation xmlns:p="http://schemas.openxmlformats.org/presentationml/2006/main">
   <p:sldMasterIdLst>
-    <p:sldMasterId xmlns:r="http://schemas.openxmlformats.org/officeDocument/2006/relationships" id="2147483648" r:id="Raa9da0edfcba47e6"/>
+    <p:sldMasterId xmlns:r="http://schemas.openxmlformats.org/officeDocument/2006/relationships" id="2147483648" r:id="R2d7f09c4e3494a48"/>
   </p:sldMasterIdLst>
   <p:notesMasterIdLst>
-    <p:notesMasterId xmlns:r="http://schemas.openxmlformats.org/officeDocument/2006/relationships" r:id="R92b98f8b6ea14fff"/>
+    <p:notesMasterId xmlns:r="http://schemas.openxmlformats.org/officeDocument/2006/relationships" r:id="Rd6a2128376c04d2e"/>
   </p:notesMasterIdLst>
   <p:sldIdLst>
-    <p:sldId xmlns:r="http://schemas.openxmlformats.org/officeDocument/2006/relationships" id="256" r:id="Re002baa30db44de1"/>
-    <p:sldId xmlns:r="http://schemas.openxmlformats.org/officeDocument/2006/relationships" id="257" r:id="R4bed4618e0a54cca"/>
-    <p:sldId xmlns:r="http://schemas.openxmlformats.org/officeDocument/2006/relationships" id="258" r:id="Rfda3e4710f08401b"/>
-    <p:sldId xmlns:r="http://schemas.openxmlformats.org/officeDocument/2006/relationships" id="259" r:id="R7b13964d4a7b42ab"/>
-    <p:sldId xmlns:r="http://schemas.openxmlformats.org/officeDocument/2006/relationships" id="260" r:id="Rc93958154559405b"/>
-    <p:sldId xmlns:r="http://schemas.openxmlformats.org/officeDocument/2006/relationships" id="261" r:id="Ra746e86a37cf4019"/>
-    <p:sldId xmlns:r="http://schemas.openxmlformats.org/officeDocument/2006/relationships" id="262" r:id="R73dcd02d607f42b5"/>
-    <p:sldId xmlns:r="http://schemas.openxmlformats.org/officeDocument/2006/relationships" id="263" r:id="R0f411710f22c4823"/>
-    <p:sldId xmlns:r="http://schemas.openxmlformats.org/officeDocument/2006/relationships" id="264" r:id="R8091219c9cb04d69"/>
+    <p:sldId xmlns:r="http://schemas.openxmlformats.org/officeDocument/2006/relationships" id="256" r:id="R86bc252a80ab45b5"/>
+    <p:sldId xmlns:r="http://schemas.openxmlformats.org/officeDocument/2006/relationships" id="257" r:id="R19defab6a4ce4221"/>
+    <p:sldId xmlns:r="http://schemas.openxmlformats.org/officeDocument/2006/relationships" id="258" r:id="R964386c313524c2c"/>
+    <p:sldId xmlns:r="http://schemas.openxmlformats.org/officeDocument/2006/relationships" id="259" r:id="R4738dadd04fa4e05"/>
+    <p:sldId xmlns:r="http://schemas.openxmlformats.org/officeDocument/2006/relationships" id="260" r:id="R5f2e918bdef945e3"/>
+    <p:sldId xmlns:r="http://schemas.openxmlformats.org/officeDocument/2006/relationships" id="261" r:id="R7eafab6110e748fa"/>
+    <p:sldId xmlns:r="http://schemas.openxmlformats.org/officeDocument/2006/relationships" id="262" r:id="Rfb3b8794f91b4f77"/>
+    <p:sldId xmlns:r="http://schemas.openxmlformats.org/officeDocument/2006/relationships" id="263" r:id="R79ac96b7c3b741f9"/>
+    <p:sldId xmlns:r="http://schemas.openxmlformats.org/officeDocument/2006/relationships" id="264" r:id="R0c2aa4df89124235"/>
   </p:sldIdLst>
   <p:sldSz cx="12192000" cy="6858000"/>
   <p:notesSz cx="6858000" cy="9144000"/>
@@ -1313,7 +1313,7 @@
   </p:cSld>
   <p:clrMap bg1="lt1" tx1="dk1" bg2="lt2" tx2="dk2" accent1="accent1" accent2="accent2" accent3="accent3" accent4="accent4" accent5="accent5" accent6="accent6" hlink="hlink" folHlink="folHlink"/>
   <p:sldLayoutIdLst>
-    <p:sldLayoutId xmlns:r="http://schemas.openxmlformats.org/officeDocument/2006/relationships" id="2147483649" r:id="Rcf82f2995d8b4588"/>
+    <p:sldLayoutId xmlns:r="http://schemas.openxmlformats.org/officeDocument/2006/relationships" id="2147483649" r:id="R62792ef662e34255"/>
   </p:sldLayoutIdLst>
   <p:txStyles>
     <p:titleStyle>
@@ -2470,7 +2470,7 @@
                   <a:srgbClr val="8EA0B8"/>
                 </a:solidFill>
               </a:rPr>
-              <a:t>AWS PUBLIC CHANGE ALERTING</a:t>
+              <a:t>© 2026 LILA BROOKS · APACHE-2.0</a:t>
             </a:r>
           </a:p>
         </p:txBody>
@@ -2701,7 +2701,7 @@
           <p:nvPr/>
         </p:nvPicPr>
         <p:blipFill>
-          <a:blip xmlns:r="http://schemas.openxmlformats.org/officeDocument/2006/relationships" xmlns:a="http://schemas.openxmlformats.org/drawingml/2006/main" r:embed="Re3d49d52ea874043"/>
+          <a:blip xmlns:r="http://schemas.openxmlformats.org/officeDocument/2006/relationships" xmlns:a="http://schemas.openxmlformats.org/drawingml/2006/main" r:embed="Rda1755c2387849b3"/>
           <a:stretch xmlns:a="http://schemas.openxmlformats.org/drawingml/2006/main"/>
         </p:blipFill>
         <p:spPr>
@@ -2842,7 +2842,7 @@
                   <a:srgbClr val="8EA0B8"/>
                 </a:solidFill>
               </a:rPr>
-              <a:t>AWS PUBLIC CHANGE ALERTING</a:t>
+              <a:t>© 2026 LILA BROOKS · APACHE-2.0</a:t>
             </a:r>
           </a:p>
         </p:txBody>
@@ -4682,7 +4682,7 @@
                   <a:srgbClr val="8EA0B8"/>
                 </a:solidFill>
               </a:rPr>
-              <a:t>AWS PUBLIC CHANGE ALERTING</a:t>
+              <a:t>© 2026 LILA BROOKS · APACHE-2.0</a:t>
             </a:r>
           </a:p>
         </p:txBody>
@@ -4997,7 +4997,7 @@
                   <a:srgbClr val="8EA0B8"/>
                 </a:solidFill>
               </a:rPr>
-              <a:t>AWS PUBLIC CHANGE ALERTING</a:t>
+              <a:t>© 2026 LILA BROOKS · APACHE-2.0</a:t>
             </a:r>
           </a:p>
         </p:txBody>
@@ -5161,6 +5161,7 @@
           <a:lstStyle xmlns:a="http://schemas.openxmlformats.org/drawingml/2006/main"/>
           <a:p xmlns:a="http://schemas.openxmlformats.org/drawingml/2006/main">
             <a:pPr algn="ctr">
+              <a:buNone/>
               <a:defRPr sz="2550" b="1">
                 <a:solidFill>
                   <a:srgbClr val="65B7FF"/>
@@ -5211,6 +5212,7 @@
           <a:lstStyle xmlns:a="http://schemas.openxmlformats.org/drawingml/2006/main"/>
           <a:p xmlns:a="http://schemas.openxmlformats.org/drawingml/2006/main">
             <a:pPr algn="ctr">
+              <a:buNone/>
               <a:defRPr sz="1800" b="1">
                 <a:solidFill>
                   <a:srgbClr val="F5F8FC"/>
@@ -5261,6 +5263,7 @@
           <a:lstStyle xmlns:a="http://schemas.openxmlformats.org/drawingml/2006/main"/>
           <a:p xmlns:a="http://schemas.openxmlformats.org/drawingml/2006/main">
             <a:pPr algn="ctr">
+              <a:buNone/>
               <a:defRPr sz="825" b="1">
                 <a:solidFill>
                   <a:srgbClr val="65B7FF"/>
@@ -5311,6 +5314,7 @@
           <a:lstStyle xmlns:a="http://schemas.openxmlformats.org/drawingml/2006/main"/>
           <a:p xmlns:a="http://schemas.openxmlformats.org/drawingml/2006/main">
             <a:pPr algn="ctr">
+              <a:buNone/>
               <a:defRPr sz="1200" b="0">
                 <a:solidFill>
                   <a:srgbClr val="D3DEEA"/>
@@ -5328,6 +5332,7 @@
           </a:p>
           <a:p xmlns:a="http://schemas.openxmlformats.org/drawingml/2006/main">
             <a:pPr algn="ctr">
+              <a:buNone/>
               <a:defRPr sz="1200" b="0">
                 <a:solidFill>
                   <a:srgbClr val="D3DEEA"/>
@@ -5345,6 +5350,7 @@
           </a:p>
           <a:p xmlns:a="http://schemas.openxmlformats.org/drawingml/2006/main">
             <a:pPr algn="ctr">
+              <a:buNone/>
               <a:defRPr sz="1200" b="0">
                 <a:solidFill>
                   <a:srgbClr val="D3DEEA"/>
@@ -5428,6 +5434,7 @@
           <a:lstStyle xmlns:a="http://schemas.openxmlformats.org/drawingml/2006/main"/>
           <a:p xmlns:a="http://schemas.openxmlformats.org/drawingml/2006/main">
             <a:pPr algn="ctr">
+              <a:buNone/>
               <a:defRPr sz="2550" b="1">
                 <a:solidFill>
                   <a:srgbClr val="56D6A3"/>
@@ -5478,6 +5485,7 @@
           <a:lstStyle xmlns:a="http://schemas.openxmlformats.org/drawingml/2006/main"/>
           <a:p xmlns:a="http://schemas.openxmlformats.org/drawingml/2006/main">
             <a:pPr algn="ctr">
+              <a:buNone/>
               <a:defRPr sz="1800" b="1">
                 <a:solidFill>
                   <a:srgbClr val="F5F8FC"/>
@@ -5528,6 +5536,7 @@
           <a:lstStyle xmlns:a="http://schemas.openxmlformats.org/drawingml/2006/main"/>
           <a:p xmlns:a="http://schemas.openxmlformats.org/drawingml/2006/main">
             <a:pPr algn="ctr">
+              <a:buNone/>
               <a:defRPr sz="825" b="1">
                 <a:solidFill>
                   <a:srgbClr val="56D6A3"/>
@@ -5578,6 +5587,7 @@
           <a:lstStyle xmlns:a="http://schemas.openxmlformats.org/drawingml/2006/main"/>
           <a:p xmlns:a="http://schemas.openxmlformats.org/drawingml/2006/main">
             <a:pPr algn="ctr">
+              <a:buNone/>
               <a:defRPr sz="1200" b="0">
                 <a:solidFill>
                   <a:srgbClr val="D3DEEA"/>
@@ -5595,6 +5605,7 @@
           </a:p>
           <a:p xmlns:a="http://schemas.openxmlformats.org/drawingml/2006/main">
             <a:pPr algn="ctr">
+              <a:buNone/>
               <a:defRPr sz="1200" b="0">
                 <a:solidFill>
                   <a:srgbClr val="D3DEEA"/>
@@ -5612,6 +5623,7 @@
           </a:p>
           <a:p xmlns:a="http://schemas.openxmlformats.org/drawingml/2006/main">
             <a:pPr algn="ctr">
+              <a:buNone/>
               <a:defRPr sz="1200" b="0">
                 <a:solidFill>
                   <a:srgbClr val="D3DEEA"/>
@@ -5695,6 +5707,7 @@
           <a:lstStyle xmlns:a="http://schemas.openxmlformats.org/drawingml/2006/main"/>
           <a:p xmlns:a="http://schemas.openxmlformats.org/drawingml/2006/main">
             <a:pPr algn="ctr">
+              <a:buNone/>
               <a:defRPr sz="2550" b="1">
                 <a:solidFill>
                   <a:srgbClr val="FF7B92"/>
@@ -5745,6 +5758,7 @@
           <a:lstStyle xmlns:a="http://schemas.openxmlformats.org/drawingml/2006/main"/>
           <a:p xmlns:a="http://schemas.openxmlformats.org/drawingml/2006/main">
             <a:pPr algn="ctr">
+              <a:buNone/>
               <a:defRPr sz="1800" b="1">
                 <a:solidFill>
                   <a:srgbClr val="F5F8FC"/>
@@ -5795,6 +5809,7 @@
           <a:lstStyle xmlns:a="http://schemas.openxmlformats.org/drawingml/2006/main"/>
           <a:p xmlns:a="http://schemas.openxmlformats.org/drawingml/2006/main">
             <a:pPr algn="ctr">
+              <a:buNone/>
               <a:defRPr sz="825" b="1">
                 <a:solidFill>
                   <a:srgbClr val="FF7B92"/>
@@ -5845,6 +5860,7 @@
           <a:lstStyle xmlns:a="http://schemas.openxmlformats.org/drawingml/2006/main"/>
           <a:p xmlns:a="http://schemas.openxmlformats.org/drawingml/2006/main">
             <a:pPr algn="ctr">
+              <a:buNone/>
               <a:defRPr sz="1200" b="0">
                 <a:solidFill>
                   <a:srgbClr val="D3DEEA"/>
@@ -5862,6 +5878,7 @@
           </a:p>
           <a:p xmlns:a="http://schemas.openxmlformats.org/drawingml/2006/main">
             <a:pPr algn="ctr">
+              <a:buNone/>
               <a:defRPr sz="1200" b="0">
                 <a:solidFill>
                   <a:srgbClr val="D3DEEA"/>
@@ -5879,6 +5896,7 @@
           </a:p>
           <a:p xmlns:a="http://schemas.openxmlformats.org/drawingml/2006/main">
             <a:pPr algn="ctr">
+              <a:buNone/>
               <a:defRPr sz="1200" b="0">
                 <a:solidFill>
                   <a:srgbClr val="D3DEEA"/>
@@ -5962,6 +5980,7 @@
           <a:lstStyle xmlns:a="http://schemas.openxmlformats.org/drawingml/2006/main"/>
           <a:p xmlns:a="http://schemas.openxmlformats.org/drawingml/2006/main">
             <a:pPr algn="ctr">
+              <a:buNone/>
               <a:defRPr sz="975" b="1">
                 <a:solidFill>
                   <a:srgbClr val="FFCB6B"/>
@@ -6012,6 +6031,7 @@
           <a:lstStyle xmlns:a="http://schemas.openxmlformats.org/drawingml/2006/main"/>
           <a:p xmlns:a="http://schemas.openxmlformats.org/drawingml/2006/main">
             <a:pPr algn="ctr">
+              <a:buNone/>
               <a:defRPr sz="1200" b="0">
                 <a:solidFill>
                   <a:srgbClr val="F5F8FC"/>
@@ -6093,6 +6113,7 @@
           <a:lstStyle xmlns:a="http://schemas.openxmlformats.org/drawingml/2006/main"/>
           <a:p xmlns:a="http://schemas.openxmlformats.org/drawingml/2006/main">
             <a:pPr algn="l">
+              <a:buNone/>
               <a:defRPr sz="750" b="1">
                 <a:solidFill>
                   <a:srgbClr val="8EA0B8"/>
@@ -6143,6 +6164,7 @@
           <a:lstStyle xmlns:a="http://schemas.openxmlformats.org/drawingml/2006/main"/>
           <a:p xmlns:a="http://schemas.openxmlformats.org/drawingml/2006/main">
             <a:pPr algn="l">
+              <a:buNone/>
               <a:defRPr sz="1125" b="1">
                 <a:solidFill>
                   <a:srgbClr val="56D6A3"/>
@@ -6193,6 +6215,7 @@
           <a:lstStyle xmlns:a="http://schemas.openxmlformats.org/drawingml/2006/main"/>
           <a:p xmlns:a="http://schemas.openxmlformats.org/drawingml/2006/main">
             <a:pPr algn="l">
+              <a:buNone/>
               <a:defRPr sz="750" b="1">
                 <a:solidFill>
                   <a:srgbClr val="8EA0B8"/>
@@ -6243,6 +6266,7 @@
           <a:lstStyle xmlns:a="http://schemas.openxmlformats.org/drawingml/2006/main"/>
           <a:p xmlns:a="http://schemas.openxmlformats.org/drawingml/2006/main">
             <a:pPr algn="l">
+              <a:buNone/>
               <a:defRPr sz="1125" b="1">
                 <a:solidFill>
                   <a:srgbClr val="FF7B92"/>
@@ -6293,6 +6317,7 @@
           <a:lstStyle xmlns:a="http://schemas.openxmlformats.org/drawingml/2006/main"/>
           <a:p xmlns:a="http://schemas.openxmlformats.org/drawingml/2006/main">
             <a:pPr algn="l">
+              <a:buNone/>
               <a:defRPr sz="750" b="1">
                 <a:solidFill>
                   <a:srgbClr val="8EA0B8"/>
@@ -6343,6 +6368,7 @@
           <a:lstStyle xmlns:a="http://schemas.openxmlformats.org/drawingml/2006/main"/>
           <a:p xmlns:a="http://schemas.openxmlformats.org/drawingml/2006/main">
             <a:pPr algn="l">
+              <a:buNone/>
               <a:defRPr sz="1125" b="1">
                 <a:solidFill>
                   <a:srgbClr val="65B7FF"/>
@@ -6393,6 +6419,7 @@
           <a:lstStyle xmlns:a="http://schemas.openxmlformats.org/drawingml/2006/main"/>
           <a:p xmlns:a="http://schemas.openxmlformats.org/drawingml/2006/main">
             <a:pPr algn="l">
+              <a:buNone/>
               <a:defRPr sz="750" b="1">
                 <a:solidFill>
                   <a:srgbClr val="8EA0B8"/>
@@ -6443,6 +6470,7 @@
           <a:lstStyle xmlns:a="http://schemas.openxmlformats.org/drawingml/2006/main"/>
           <a:p xmlns:a="http://schemas.openxmlformats.org/drawingml/2006/main">
             <a:pPr algn="l">
+              <a:buNone/>
               <a:defRPr sz="1125" b="1">
                 <a:solidFill>
                   <a:srgbClr val="FFCB6B"/>
@@ -6770,7 +6798,7 @@
                   <a:srgbClr val="8EA0B8"/>
                 </a:solidFill>
               </a:rPr>
-              <a:t>AWS PUBLIC CHANGE ALERTING</a:t>
+              <a:t>© 2026 LILA BROOKS · APACHE-2.0</a:t>
             </a:r>
           </a:p>
         </p:txBody>
@@ -6808,6 +6836,7 @@
           <a:lstStyle xmlns:a="http://schemas.openxmlformats.org/drawingml/2006/main"/>
           <a:p xmlns:a="http://schemas.openxmlformats.org/drawingml/2006/main">
             <a:pPr algn="l">
+              <a:buNone/>
               <a:defRPr sz="4800" b="1">
                 <a:solidFill>
                   <a:srgbClr val="F5F8FC"/>
@@ -6858,6 +6887,7 @@
           <a:lstStyle xmlns:a="http://schemas.openxmlformats.org/drawingml/2006/main"/>
           <a:p xmlns:a="http://schemas.openxmlformats.org/drawingml/2006/main">
             <a:pPr algn="l">
+              <a:buNone/>
               <a:defRPr sz="1650" b="1">
                 <a:solidFill>
                   <a:srgbClr val="D3DEEA"/>
@@ -6908,6 +6938,7 @@
           <a:lstStyle xmlns:a="http://schemas.openxmlformats.org/drawingml/2006/main"/>
           <a:p xmlns:a="http://schemas.openxmlformats.org/drawingml/2006/main">
             <a:pPr algn="l">
+              <a:buNone/>
               <a:defRPr sz="1350" b="1">
                 <a:solidFill>
                   <a:srgbClr val="65B7FF"/>
@@ -6958,6 +6989,7 @@
           <a:lstStyle xmlns:a="http://schemas.openxmlformats.org/drawingml/2006/main"/>
           <a:p xmlns:a="http://schemas.openxmlformats.org/drawingml/2006/main">
             <a:pPr algn="l">
+              <a:buNone/>
               <a:defRPr sz="1350" b="1">
                 <a:solidFill>
                   <a:srgbClr val="B69DF8"/>
@@ -7113,6 +7145,7 @@
           <a:lstStyle xmlns:a="http://schemas.openxmlformats.org/drawingml/2006/main"/>
           <a:p xmlns:a="http://schemas.openxmlformats.org/drawingml/2006/main">
             <a:pPr algn="l">
+              <a:buNone/>
               <a:defRPr sz="1200" b="0">
                 <a:solidFill>
                   <a:srgbClr val="8EA0B8"/>
@@ -7194,6 +7227,7 @@
           <a:lstStyle xmlns:a="http://schemas.openxmlformats.org/drawingml/2006/main"/>
           <a:p xmlns:a="http://schemas.openxmlformats.org/drawingml/2006/main">
             <a:pPr algn="ctr">
+              <a:buNone/>
               <a:defRPr sz="3900" b="1">
                 <a:solidFill>
                   <a:srgbClr val="56D6A3"/>
@@ -7244,6 +7278,7 @@
           <a:lstStyle xmlns:a="http://schemas.openxmlformats.org/drawingml/2006/main"/>
           <a:p xmlns:a="http://schemas.openxmlformats.org/drawingml/2006/main">
             <a:pPr algn="ctr">
+              <a:buNone/>
               <a:defRPr sz="1575" b="1">
                 <a:solidFill>
                   <a:srgbClr val="F5F8FC"/>
@@ -7294,6 +7329,7 @@
           <a:lstStyle xmlns:a="http://schemas.openxmlformats.org/drawingml/2006/main"/>
           <a:p xmlns:a="http://schemas.openxmlformats.org/drawingml/2006/main">
             <a:pPr algn="ctr">
+              <a:buNone/>
               <a:defRPr sz="1050" b="1">
                 <a:solidFill>
                   <a:srgbClr val="8EA0B8"/>
@@ -7344,6 +7380,7 @@
           <a:lstStyle xmlns:a="http://schemas.openxmlformats.org/drawingml/2006/main"/>
           <a:p xmlns:a="http://schemas.openxmlformats.org/drawingml/2006/main">
             <a:pPr algn="ctr">
+              <a:buNone/>
               <a:defRPr sz="3900" b="1">
                 <a:solidFill>
                   <a:srgbClr val="65B7FF"/>
@@ -7394,6 +7431,7 @@
           <a:lstStyle xmlns:a="http://schemas.openxmlformats.org/drawingml/2006/main"/>
           <a:p xmlns:a="http://schemas.openxmlformats.org/drawingml/2006/main">
             <a:pPr algn="ctr">
+              <a:buNone/>
               <a:defRPr sz="1575" b="1">
                 <a:solidFill>
                   <a:srgbClr val="F5F8FC"/>
@@ -7444,6 +7482,7 @@
           <a:lstStyle xmlns:a="http://schemas.openxmlformats.org/drawingml/2006/main"/>
           <a:p xmlns:a="http://schemas.openxmlformats.org/drawingml/2006/main">
             <a:pPr algn="ctr">
+              <a:buNone/>
               <a:defRPr sz="1050" b="1">
                 <a:solidFill>
                   <a:srgbClr val="8EA0B8"/>
@@ -7527,6 +7566,7 @@
           <a:lstStyle xmlns:a="http://schemas.openxmlformats.org/drawingml/2006/main"/>
           <a:p xmlns:a="http://schemas.openxmlformats.org/drawingml/2006/main">
             <a:pPr algn="ctr">
+              <a:buNone/>
               <a:defRPr sz="2100" b="1">
                 <a:solidFill>
                   <a:srgbClr val="56D6A3"/>
@@ -7577,6 +7617,7 @@
           <a:lstStyle xmlns:a="http://schemas.openxmlformats.org/drawingml/2006/main"/>
           <a:p xmlns:a="http://schemas.openxmlformats.org/drawingml/2006/main">
             <a:pPr algn="ctr">
+              <a:buNone/>
               <a:defRPr sz="975" b="0">
                 <a:solidFill>
                   <a:srgbClr val="D3DEEA"/>
@@ -7627,6 +7668,7 @@
           <a:lstStyle xmlns:a="http://schemas.openxmlformats.org/drawingml/2006/main"/>
           <a:p xmlns:a="http://schemas.openxmlformats.org/drawingml/2006/main">
             <a:pPr algn="ctr">
+              <a:buNone/>
               <a:defRPr sz="2100" b="1">
                 <a:solidFill>
                   <a:srgbClr val="FF7B92"/>
@@ -7677,6 +7719,7 @@
           <a:lstStyle xmlns:a="http://schemas.openxmlformats.org/drawingml/2006/main"/>
           <a:p xmlns:a="http://schemas.openxmlformats.org/drawingml/2006/main">
             <a:pPr algn="ctr">
+              <a:buNone/>
               <a:defRPr sz="975" b="0">
                 <a:solidFill>
                   <a:srgbClr val="D3DEEA"/>
@@ -7727,6 +7770,7 @@
           <a:lstStyle xmlns:a="http://schemas.openxmlformats.org/drawingml/2006/main"/>
           <a:p xmlns:a="http://schemas.openxmlformats.org/drawingml/2006/main">
             <a:pPr algn="ctr">
+              <a:buNone/>
               <a:defRPr sz="2100" b="1">
                 <a:solidFill>
                   <a:srgbClr val="FFCB6B"/>
@@ -7777,6 +7821,7 @@
           <a:lstStyle xmlns:a="http://schemas.openxmlformats.org/drawingml/2006/main"/>
           <a:p xmlns:a="http://schemas.openxmlformats.org/drawingml/2006/main">
             <a:pPr algn="ctr">
+              <a:buNone/>
               <a:defRPr sz="975" b="0">
                 <a:solidFill>
                   <a:srgbClr val="D3DEEA"/>
@@ -7860,6 +7905,7 @@
           <a:lstStyle xmlns:a="http://schemas.openxmlformats.org/drawingml/2006/main"/>
           <a:p xmlns:a="http://schemas.openxmlformats.org/drawingml/2006/main">
             <a:pPr algn="l">
+              <a:buNone/>
               <a:defRPr sz="750" b="1">
                 <a:solidFill>
                   <a:srgbClr val="B69DF8"/>
@@ -7910,6 +7956,7 @@
           <a:lstStyle xmlns:a="http://schemas.openxmlformats.org/drawingml/2006/main"/>
           <a:p xmlns:a="http://schemas.openxmlformats.org/drawingml/2006/main">
             <a:pPr algn="l">
+              <a:buNone/>
               <a:defRPr sz="1125" b="0">
                 <a:solidFill>
                   <a:srgbClr val="F5F8FC"/>
@@ -7991,6 +8038,7 @@
           <a:lstStyle xmlns:a="http://schemas.openxmlformats.org/drawingml/2006/main"/>
           <a:p xmlns:a="http://schemas.openxmlformats.org/drawingml/2006/main">
             <a:pPr algn="l">
+              <a:buNone/>
               <a:defRPr sz="750" b="1">
                 <a:solidFill>
                   <a:srgbClr val="8EA0B8"/>
@@ -8041,6 +8089,7 @@
           <a:lstStyle xmlns:a="http://schemas.openxmlformats.org/drawingml/2006/main"/>
           <a:p xmlns:a="http://schemas.openxmlformats.org/drawingml/2006/main">
             <a:pPr algn="l">
+              <a:buNone/>
               <a:defRPr sz="1275" b="1">
                 <a:solidFill>
                   <a:srgbClr val="56D6A3"/>
@@ -8091,6 +8140,7 @@
           <a:lstStyle xmlns:a="http://schemas.openxmlformats.org/drawingml/2006/main"/>
           <a:p xmlns:a="http://schemas.openxmlformats.org/drawingml/2006/main">
             <a:pPr algn="l">
+              <a:buNone/>
               <a:defRPr sz="750" b="1">
                 <a:solidFill>
                   <a:srgbClr val="8EA0B8"/>
@@ -8141,6 +8191,7 @@
           <a:lstStyle xmlns:a="http://schemas.openxmlformats.org/drawingml/2006/main"/>
           <a:p xmlns:a="http://schemas.openxmlformats.org/drawingml/2006/main">
             <a:pPr algn="l">
+              <a:buNone/>
               <a:defRPr sz="1275" b="1">
                 <a:solidFill>
                   <a:srgbClr val="65B7FF"/>
@@ -8191,6 +8242,7 @@
           <a:lstStyle xmlns:a="http://schemas.openxmlformats.org/drawingml/2006/main"/>
           <a:p xmlns:a="http://schemas.openxmlformats.org/drawingml/2006/main">
             <a:pPr algn="l">
+              <a:buNone/>
               <a:defRPr sz="750" b="1">
                 <a:solidFill>
                   <a:srgbClr val="8EA0B8"/>
@@ -8241,6 +8293,7 @@
           <a:lstStyle xmlns:a="http://schemas.openxmlformats.org/drawingml/2006/main"/>
           <a:p xmlns:a="http://schemas.openxmlformats.org/drawingml/2006/main">
             <a:pPr algn="l">
+              <a:buNone/>
               <a:defRPr sz="1275" b="1">
                 <a:solidFill>
                   <a:srgbClr val="B69DF8"/>
@@ -8291,6 +8344,7 @@
           <a:lstStyle xmlns:a="http://schemas.openxmlformats.org/drawingml/2006/main"/>
           <a:p xmlns:a="http://schemas.openxmlformats.org/drawingml/2006/main">
             <a:pPr algn="l">
+              <a:buNone/>
               <a:defRPr sz="750" b="1">
                 <a:solidFill>
                   <a:srgbClr val="8EA0B8"/>
@@ -8341,6 +8395,7 @@
           <a:lstStyle xmlns:a="http://schemas.openxmlformats.org/drawingml/2006/main"/>
           <a:p xmlns:a="http://schemas.openxmlformats.org/drawingml/2006/main">
             <a:pPr algn="l">
+              <a:buNone/>
               <a:defRPr sz="1125" b="1">
                 <a:solidFill>
                   <a:srgbClr val="FFCB6B"/>
@@ -9986,7 +10041,7 @@
                   <a:srgbClr val="8EA0B8"/>
                 </a:solidFill>
               </a:rPr>
-              <a:t>AWS PUBLIC CHANGE ALERTING</a:t>
+              <a:t>© 2026 LILA BROOKS · APACHE-2.0</a:t>
             </a:r>
           </a:p>
         </p:txBody>
@@ -11558,7 +11613,7 @@
                   <a:srgbClr val="8EA0B8"/>
                 </a:solidFill>
               </a:rPr>
-              <a:t>AWS PUBLIC CHANGE ALERTING</a:t>
+              <a:t>© 2026 LILA BROOKS · APACHE-2.0</a:t>
             </a:r>
           </a:p>
         </p:txBody>
@@ -11789,7 +11844,7 @@
           <p:nvPr/>
         </p:nvPicPr>
         <p:blipFill>
-          <a:blip xmlns:r="http://schemas.openxmlformats.org/officeDocument/2006/relationships" xmlns:a="http://schemas.openxmlformats.org/drawingml/2006/main" r:embed="R9efd2ddc9546426a"/>
+          <a:blip xmlns:r="http://schemas.openxmlformats.org/officeDocument/2006/relationships" xmlns:a="http://schemas.openxmlformats.org/drawingml/2006/main" r:embed="Ra88c3f8db3994aa7"/>
           <a:stretch xmlns:a="http://schemas.openxmlformats.org/drawingml/2006/main"/>
         </p:blipFill>
         <p:spPr>
@@ -12269,7 +12324,7 @@
                   <a:srgbClr val="8EA0B8"/>
                 </a:solidFill>
               </a:rPr>
-              <a:t>AWS PUBLIC CHANGE ALERTING</a:t>
+              <a:t>© 2026 LILA BROOKS · APACHE-2.0</a:t>
             </a:r>
           </a:p>
         </p:txBody>
@@ -13619,7 +13674,7 @@
                   <a:srgbClr val="8EA0B8"/>
                 </a:solidFill>
               </a:rPr>
-              <a:t>Status source: README project table · accepted ADR-024</a:t>
+              <a:t>Status source: README project table · accepted ADR-024 · github.com/lilabrooks/aws-public-change-feed</a:t>
             </a:r>
           </a:p>
         </p:txBody>
@@ -13670,7 +13725,7 @@
                   <a:srgbClr val="8EA0B8"/>
                 </a:solidFill>
               </a:rPr>
-              <a:t>AWS PUBLIC CHANGE ALERTING</a:t>
+              <a:t>© 2026 LILA BROOKS · APACHE-2.0</a:t>
             </a:r>
           </a:p>
         </p:txBody>

</xml_diff>

<commit_message>
docs: add copyright to MVP evidence media (#154)
</commit_message>
<xml_diff>
--- a/site/media/mvp-evidence-v2/aws-public-change-alerting-mvp-evidence-v2.pptx
+++ b/site/media/mvp-evidence-v2/aws-public-change-alerting-mvp-evidence-v2.pptx
@@ -2,21 +2,21 @@
 <file path=ppt/presentation.xml><?xml version="1.0" encoding="utf-8"?>
 <p:presentation xmlns:p="http://schemas.openxmlformats.org/presentationml/2006/main">
   <p:sldMasterIdLst>
-    <p:sldMasterId xmlns:r="http://schemas.openxmlformats.org/officeDocument/2006/relationships" id="2147483648" r:id="Raa9da0edfcba47e6"/>
+    <p:sldMasterId xmlns:r="http://schemas.openxmlformats.org/officeDocument/2006/relationships" id="2147483648" r:id="R2d7f09c4e3494a48"/>
   </p:sldMasterIdLst>
   <p:notesMasterIdLst>
-    <p:notesMasterId xmlns:r="http://schemas.openxmlformats.org/officeDocument/2006/relationships" r:id="R92b98f8b6ea14fff"/>
+    <p:notesMasterId xmlns:r="http://schemas.openxmlformats.org/officeDocument/2006/relationships" r:id="Rd6a2128376c04d2e"/>
   </p:notesMasterIdLst>
   <p:sldIdLst>
-    <p:sldId xmlns:r="http://schemas.openxmlformats.org/officeDocument/2006/relationships" id="256" r:id="Re002baa30db44de1"/>
-    <p:sldId xmlns:r="http://schemas.openxmlformats.org/officeDocument/2006/relationships" id="257" r:id="R4bed4618e0a54cca"/>
-    <p:sldId xmlns:r="http://schemas.openxmlformats.org/officeDocument/2006/relationships" id="258" r:id="Rfda3e4710f08401b"/>
-    <p:sldId xmlns:r="http://schemas.openxmlformats.org/officeDocument/2006/relationships" id="259" r:id="R7b13964d4a7b42ab"/>
-    <p:sldId xmlns:r="http://schemas.openxmlformats.org/officeDocument/2006/relationships" id="260" r:id="Rc93958154559405b"/>
-    <p:sldId xmlns:r="http://schemas.openxmlformats.org/officeDocument/2006/relationships" id="261" r:id="Ra746e86a37cf4019"/>
-    <p:sldId xmlns:r="http://schemas.openxmlformats.org/officeDocument/2006/relationships" id="262" r:id="R73dcd02d607f42b5"/>
-    <p:sldId xmlns:r="http://schemas.openxmlformats.org/officeDocument/2006/relationships" id="263" r:id="R0f411710f22c4823"/>
-    <p:sldId xmlns:r="http://schemas.openxmlformats.org/officeDocument/2006/relationships" id="264" r:id="R8091219c9cb04d69"/>
+    <p:sldId xmlns:r="http://schemas.openxmlformats.org/officeDocument/2006/relationships" id="256" r:id="R86bc252a80ab45b5"/>
+    <p:sldId xmlns:r="http://schemas.openxmlformats.org/officeDocument/2006/relationships" id="257" r:id="R19defab6a4ce4221"/>
+    <p:sldId xmlns:r="http://schemas.openxmlformats.org/officeDocument/2006/relationships" id="258" r:id="R964386c313524c2c"/>
+    <p:sldId xmlns:r="http://schemas.openxmlformats.org/officeDocument/2006/relationships" id="259" r:id="R4738dadd04fa4e05"/>
+    <p:sldId xmlns:r="http://schemas.openxmlformats.org/officeDocument/2006/relationships" id="260" r:id="R5f2e918bdef945e3"/>
+    <p:sldId xmlns:r="http://schemas.openxmlformats.org/officeDocument/2006/relationships" id="261" r:id="R7eafab6110e748fa"/>
+    <p:sldId xmlns:r="http://schemas.openxmlformats.org/officeDocument/2006/relationships" id="262" r:id="Rfb3b8794f91b4f77"/>
+    <p:sldId xmlns:r="http://schemas.openxmlformats.org/officeDocument/2006/relationships" id="263" r:id="R79ac96b7c3b741f9"/>
+    <p:sldId xmlns:r="http://schemas.openxmlformats.org/officeDocument/2006/relationships" id="264" r:id="R0c2aa4df89124235"/>
   </p:sldIdLst>
   <p:sldSz cx="12192000" cy="6858000"/>
   <p:notesSz cx="6858000" cy="9144000"/>
@@ -1313,7 +1313,7 @@
   </p:cSld>
   <p:clrMap bg1="lt1" tx1="dk1" bg2="lt2" tx2="dk2" accent1="accent1" accent2="accent2" accent3="accent3" accent4="accent4" accent5="accent5" accent6="accent6" hlink="hlink" folHlink="folHlink"/>
   <p:sldLayoutIdLst>
-    <p:sldLayoutId xmlns:r="http://schemas.openxmlformats.org/officeDocument/2006/relationships" id="2147483649" r:id="Rcf82f2995d8b4588"/>
+    <p:sldLayoutId xmlns:r="http://schemas.openxmlformats.org/officeDocument/2006/relationships" id="2147483649" r:id="R62792ef662e34255"/>
   </p:sldLayoutIdLst>
   <p:txStyles>
     <p:titleStyle>
@@ -2470,7 +2470,7 @@
                   <a:srgbClr val="8EA0B8"/>
                 </a:solidFill>
               </a:rPr>
-              <a:t>AWS PUBLIC CHANGE ALERTING</a:t>
+              <a:t>© 2026 LILA BROOKS · APACHE-2.0</a:t>
             </a:r>
           </a:p>
         </p:txBody>
@@ -2701,7 +2701,7 @@
           <p:nvPr/>
         </p:nvPicPr>
         <p:blipFill>
-          <a:blip xmlns:r="http://schemas.openxmlformats.org/officeDocument/2006/relationships" xmlns:a="http://schemas.openxmlformats.org/drawingml/2006/main" r:embed="Re3d49d52ea874043"/>
+          <a:blip xmlns:r="http://schemas.openxmlformats.org/officeDocument/2006/relationships" xmlns:a="http://schemas.openxmlformats.org/drawingml/2006/main" r:embed="Rda1755c2387849b3"/>
           <a:stretch xmlns:a="http://schemas.openxmlformats.org/drawingml/2006/main"/>
         </p:blipFill>
         <p:spPr>
@@ -2842,7 +2842,7 @@
                   <a:srgbClr val="8EA0B8"/>
                 </a:solidFill>
               </a:rPr>
-              <a:t>AWS PUBLIC CHANGE ALERTING</a:t>
+              <a:t>© 2026 LILA BROOKS · APACHE-2.0</a:t>
             </a:r>
           </a:p>
         </p:txBody>
@@ -4682,7 +4682,7 @@
                   <a:srgbClr val="8EA0B8"/>
                 </a:solidFill>
               </a:rPr>
-              <a:t>AWS PUBLIC CHANGE ALERTING</a:t>
+              <a:t>© 2026 LILA BROOKS · APACHE-2.0</a:t>
             </a:r>
           </a:p>
         </p:txBody>
@@ -4997,7 +4997,7 @@
                   <a:srgbClr val="8EA0B8"/>
                 </a:solidFill>
               </a:rPr>
-              <a:t>AWS PUBLIC CHANGE ALERTING</a:t>
+              <a:t>© 2026 LILA BROOKS · APACHE-2.0</a:t>
             </a:r>
           </a:p>
         </p:txBody>
@@ -5161,6 +5161,7 @@
           <a:lstStyle xmlns:a="http://schemas.openxmlformats.org/drawingml/2006/main"/>
           <a:p xmlns:a="http://schemas.openxmlformats.org/drawingml/2006/main">
             <a:pPr algn="ctr">
+              <a:buNone/>
               <a:defRPr sz="2550" b="1">
                 <a:solidFill>
                   <a:srgbClr val="65B7FF"/>
@@ -5211,6 +5212,7 @@
           <a:lstStyle xmlns:a="http://schemas.openxmlformats.org/drawingml/2006/main"/>
           <a:p xmlns:a="http://schemas.openxmlformats.org/drawingml/2006/main">
             <a:pPr algn="ctr">
+              <a:buNone/>
               <a:defRPr sz="1800" b="1">
                 <a:solidFill>
                   <a:srgbClr val="F5F8FC"/>
@@ -5261,6 +5263,7 @@
           <a:lstStyle xmlns:a="http://schemas.openxmlformats.org/drawingml/2006/main"/>
           <a:p xmlns:a="http://schemas.openxmlformats.org/drawingml/2006/main">
             <a:pPr algn="ctr">
+              <a:buNone/>
               <a:defRPr sz="825" b="1">
                 <a:solidFill>
                   <a:srgbClr val="65B7FF"/>
@@ -5311,6 +5314,7 @@
           <a:lstStyle xmlns:a="http://schemas.openxmlformats.org/drawingml/2006/main"/>
           <a:p xmlns:a="http://schemas.openxmlformats.org/drawingml/2006/main">
             <a:pPr algn="ctr">
+              <a:buNone/>
               <a:defRPr sz="1200" b="0">
                 <a:solidFill>
                   <a:srgbClr val="D3DEEA"/>
@@ -5328,6 +5332,7 @@
           </a:p>
           <a:p xmlns:a="http://schemas.openxmlformats.org/drawingml/2006/main">
             <a:pPr algn="ctr">
+              <a:buNone/>
               <a:defRPr sz="1200" b="0">
                 <a:solidFill>
                   <a:srgbClr val="D3DEEA"/>
@@ -5345,6 +5350,7 @@
           </a:p>
           <a:p xmlns:a="http://schemas.openxmlformats.org/drawingml/2006/main">
             <a:pPr algn="ctr">
+              <a:buNone/>
               <a:defRPr sz="1200" b="0">
                 <a:solidFill>
                   <a:srgbClr val="D3DEEA"/>
@@ -5428,6 +5434,7 @@
           <a:lstStyle xmlns:a="http://schemas.openxmlformats.org/drawingml/2006/main"/>
           <a:p xmlns:a="http://schemas.openxmlformats.org/drawingml/2006/main">
             <a:pPr algn="ctr">
+              <a:buNone/>
               <a:defRPr sz="2550" b="1">
                 <a:solidFill>
                   <a:srgbClr val="56D6A3"/>
@@ -5478,6 +5485,7 @@
           <a:lstStyle xmlns:a="http://schemas.openxmlformats.org/drawingml/2006/main"/>
           <a:p xmlns:a="http://schemas.openxmlformats.org/drawingml/2006/main">
             <a:pPr algn="ctr">
+              <a:buNone/>
               <a:defRPr sz="1800" b="1">
                 <a:solidFill>
                   <a:srgbClr val="F5F8FC"/>
@@ -5528,6 +5536,7 @@
           <a:lstStyle xmlns:a="http://schemas.openxmlformats.org/drawingml/2006/main"/>
           <a:p xmlns:a="http://schemas.openxmlformats.org/drawingml/2006/main">
             <a:pPr algn="ctr">
+              <a:buNone/>
               <a:defRPr sz="825" b="1">
                 <a:solidFill>
                   <a:srgbClr val="56D6A3"/>
@@ -5578,6 +5587,7 @@
           <a:lstStyle xmlns:a="http://schemas.openxmlformats.org/drawingml/2006/main"/>
           <a:p xmlns:a="http://schemas.openxmlformats.org/drawingml/2006/main">
             <a:pPr algn="ctr">
+              <a:buNone/>
               <a:defRPr sz="1200" b="0">
                 <a:solidFill>
                   <a:srgbClr val="D3DEEA"/>
@@ -5595,6 +5605,7 @@
           </a:p>
           <a:p xmlns:a="http://schemas.openxmlformats.org/drawingml/2006/main">
             <a:pPr algn="ctr">
+              <a:buNone/>
               <a:defRPr sz="1200" b="0">
                 <a:solidFill>
                   <a:srgbClr val="D3DEEA"/>
@@ -5612,6 +5623,7 @@
           </a:p>
           <a:p xmlns:a="http://schemas.openxmlformats.org/drawingml/2006/main">
             <a:pPr algn="ctr">
+              <a:buNone/>
               <a:defRPr sz="1200" b="0">
                 <a:solidFill>
                   <a:srgbClr val="D3DEEA"/>
@@ -5695,6 +5707,7 @@
           <a:lstStyle xmlns:a="http://schemas.openxmlformats.org/drawingml/2006/main"/>
           <a:p xmlns:a="http://schemas.openxmlformats.org/drawingml/2006/main">
             <a:pPr algn="ctr">
+              <a:buNone/>
               <a:defRPr sz="2550" b="1">
                 <a:solidFill>
                   <a:srgbClr val="FF7B92"/>
@@ -5745,6 +5758,7 @@
           <a:lstStyle xmlns:a="http://schemas.openxmlformats.org/drawingml/2006/main"/>
           <a:p xmlns:a="http://schemas.openxmlformats.org/drawingml/2006/main">
             <a:pPr algn="ctr">
+              <a:buNone/>
               <a:defRPr sz="1800" b="1">
                 <a:solidFill>
                   <a:srgbClr val="F5F8FC"/>
@@ -5795,6 +5809,7 @@
           <a:lstStyle xmlns:a="http://schemas.openxmlformats.org/drawingml/2006/main"/>
           <a:p xmlns:a="http://schemas.openxmlformats.org/drawingml/2006/main">
             <a:pPr algn="ctr">
+              <a:buNone/>
               <a:defRPr sz="825" b="1">
                 <a:solidFill>
                   <a:srgbClr val="FF7B92"/>
@@ -5845,6 +5860,7 @@
           <a:lstStyle xmlns:a="http://schemas.openxmlformats.org/drawingml/2006/main"/>
           <a:p xmlns:a="http://schemas.openxmlformats.org/drawingml/2006/main">
             <a:pPr algn="ctr">
+              <a:buNone/>
               <a:defRPr sz="1200" b="0">
                 <a:solidFill>
                   <a:srgbClr val="D3DEEA"/>
@@ -5862,6 +5878,7 @@
           </a:p>
           <a:p xmlns:a="http://schemas.openxmlformats.org/drawingml/2006/main">
             <a:pPr algn="ctr">
+              <a:buNone/>
               <a:defRPr sz="1200" b="0">
                 <a:solidFill>
                   <a:srgbClr val="D3DEEA"/>
@@ -5879,6 +5896,7 @@
           </a:p>
           <a:p xmlns:a="http://schemas.openxmlformats.org/drawingml/2006/main">
             <a:pPr algn="ctr">
+              <a:buNone/>
               <a:defRPr sz="1200" b="0">
                 <a:solidFill>
                   <a:srgbClr val="D3DEEA"/>
@@ -5962,6 +5980,7 @@
           <a:lstStyle xmlns:a="http://schemas.openxmlformats.org/drawingml/2006/main"/>
           <a:p xmlns:a="http://schemas.openxmlformats.org/drawingml/2006/main">
             <a:pPr algn="ctr">
+              <a:buNone/>
               <a:defRPr sz="975" b="1">
                 <a:solidFill>
                   <a:srgbClr val="FFCB6B"/>
@@ -6012,6 +6031,7 @@
           <a:lstStyle xmlns:a="http://schemas.openxmlformats.org/drawingml/2006/main"/>
           <a:p xmlns:a="http://schemas.openxmlformats.org/drawingml/2006/main">
             <a:pPr algn="ctr">
+              <a:buNone/>
               <a:defRPr sz="1200" b="0">
                 <a:solidFill>
                   <a:srgbClr val="F5F8FC"/>
@@ -6093,6 +6113,7 @@
           <a:lstStyle xmlns:a="http://schemas.openxmlformats.org/drawingml/2006/main"/>
           <a:p xmlns:a="http://schemas.openxmlformats.org/drawingml/2006/main">
             <a:pPr algn="l">
+              <a:buNone/>
               <a:defRPr sz="750" b="1">
                 <a:solidFill>
                   <a:srgbClr val="8EA0B8"/>
@@ -6143,6 +6164,7 @@
           <a:lstStyle xmlns:a="http://schemas.openxmlformats.org/drawingml/2006/main"/>
           <a:p xmlns:a="http://schemas.openxmlformats.org/drawingml/2006/main">
             <a:pPr algn="l">
+              <a:buNone/>
               <a:defRPr sz="1125" b="1">
                 <a:solidFill>
                   <a:srgbClr val="56D6A3"/>
@@ -6193,6 +6215,7 @@
           <a:lstStyle xmlns:a="http://schemas.openxmlformats.org/drawingml/2006/main"/>
           <a:p xmlns:a="http://schemas.openxmlformats.org/drawingml/2006/main">
             <a:pPr algn="l">
+              <a:buNone/>
               <a:defRPr sz="750" b="1">
                 <a:solidFill>
                   <a:srgbClr val="8EA0B8"/>
@@ -6243,6 +6266,7 @@
           <a:lstStyle xmlns:a="http://schemas.openxmlformats.org/drawingml/2006/main"/>
           <a:p xmlns:a="http://schemas.openxmlformats.org/drawingml/2006/main">
             <a:pPr algn="l">
+              <a:buNone/>
               <a:defRPr sz="1125" b="1">
                 <a:solidFill>
                   <a:srgbClr val="FF7B92"/>
@@ -6293,6 +6317,7 @@
           <a:lstStyle xmlns:a="http://schemas.openxmlformats.org/drawingml/2006/main"/>
           <a:p xmlns:a="http://schemas.openxmlformats.org/drawingml/2006/main">
             <a:pPr algn="l">
+              <a:buNone/>
               <a:defRPr sz="750" b="1">
                 <a:solidFill>
                   <a:srgbClr val="8EA0B8"/>
@@ -6343,6 +6368,7 @@
           <a:lstStyle xmlns:a="http://schemas.openxmlformats.org/drawingml/2006/main"/>
           <a:p xmlns:a="http://schemas.openxmlformats.org/drawingml/2006/main">
             <a:pPr algn="l">
+              <a:buNone/>
               <a:defRPr sz="1125" b="1">
                 <a:solidFill>
                   <a:srgbClr val="65B7FF"/>
@@ -6393,6 +6419,7 @@
           <a:lstStyle xmlns:a="http://schemas.openxmlformats.org/drawingml/2006/main"/>
           <a:p xmlns:a="http://schemas.openxmlformats.org/drawingml/2006/main">
             <a:pPr algn="l">
+              <a:buNone/>
               <a:defRPr sz="750" b="1">
                 <a:solidFill>
                   <a:srgbClr val="8EA0B8"/>
@@ -6443,6 +6470,7 @@
           <a:lstStyle xmlns:a="http://schemas.openxmlformats.org/drawingml/2006/main"/>
           <a:p xmlns:a="http://schemas.openxmlformats.org/drawingml/2006/main">
             <a:pPr algn="l">
+              <a:buNone/>
               <a:defRPr sz="1125" b="1">
                 <a:solidFill>
                   <a:srgbClr val="FFCB6B"/>
@@ -6770,7 +6798,7 @@
                   <a:srgbClr val="8EA0B8"/>
                 </a:solidFill>
               </a:rPr>
-              <a:t>AWS PUBLIC CHANGE ALERTING</a:t>
+              <a:t>© 2026 LILA BROOKS · APACHE-2.0</a:t>
             </a:r>
           </a:p>
         </p:txBody>
@@ -6808,6 +6836,7 @@
           <a:lstStyle xmlns:a="http://schemas.openxmlformats.org/drawingml/2006/main"/>
           <a:p xmlns:a="http://schemas.openxmlformats.org/drawingml/2006/main">
             <a:pPr algn="l">
+              <a:buNone/>
               <a:defRPr sz="4800" b="1">
                 <a:solidFill>
                   <a:srgbClr val="F5F8FC"/>
@@ -6858,6 +6887,7 @@
           <a:lstStyle xmlns:a="http://schemas.openxmlformats.org/drawingml/2006/main"/>
           <a:p xmlns:a="http://schemas.openxmlformats.org/drawingml/2006/main">
             <a:pPr algn="l">
+              <a:buNone/>
               <a:defRPr sz="1650" b="1">
                 <a:solidFill>
                   <a:srgbClr val="D3DEEA"/>
@@ -6908,6 +6938,7 @@
           <a:lstStyle xmlns:a="http://schemas.openxmlformats.org/drawingml/2006/main"/>
           <a:p xmlns:a="http://schemas.openxmlformats.org/drawingml/2006/main">
             <a:pPr algn="l">
+              <a:buNone/>
               <a:defRPr sz="1350" b="1">
                 <a:solidFill>
                   <a:srgbClr val="65B7FF"/>
@@ -6958,6 +6989,7 @@
           <a:lstStyle xmlns:a="http://schemas.openxmlformats.org/drawingml/2006/main"/>
           <a:p xmlns:a="http://schemas.openxmlformats.org/drawingml/2006/main">
             <a:pPr algn="l">
+              <a:buNone/>
               <a:defRPr sz="1350" b="1">
                 <a:solidFill>
                   <a:srgbClr val="B69DF8"/>
@@ -7113,6 +7145,7 @@
           <a:lstStyle xmlns:a="http://schemas.openxmlformats.org/drawingml/2006/main"/>
           <a:p xmlns:a="http://schemas.openxmlformats.org/drawingml/2006/main">
             <a:pPr algn="l">
+              <a:buNone/>
               <a:defRPr sz="1200" b="0">
                 <a:solidFill>
                   <a:srgbClr val="8EA0B8"/>
@@ -7194,6 +7227,7 @@
           <a:lstStyle xmlns:a="http://schemas.openxmlformats.org/drawingml/2006/main"/>
           <a:p xmlns:a="http://schemas.openxmlformats.org/drawingml/2006/main">
             <a:pPr algn="ctr">
+              <a:buNone/>
               <a:defRPr sz="3900" b="1">
                 <a:solidFill>
                   <a:srgbClr val="56D6A3"/>
@@ -7244,6 +7278,7 @@
           <a:lstStyle xmlns:a="http://schemas.openxmlformats.org/drawingml/2006/main"/>
           <a:p xmlns:a="http://schemas.openxmlformats.org/drawingml/2006/main">
             <a:pPr algn="ctr">
+              <a:buNone/>
               <a:defRPr sz="1575" b="1">
                 <a:solidFill>
                   <a:srgbClr val="F5F8FC"/>
@@ -7294,6 +7329,7 @@
           <a:lstStyle xmlns:a="http://schemas.openxmlformats.org/drawingml/2006/main"/>
           <a:p xmlns:a="http://schemas.openxmlformats.org/drawingml/2006/main">
             <a:pPr algn="ctr">
+              <a:buNone/>
               <a:defRPr sz="1050" b="1">
                 <a:solidFill>
                   <a:srgbClr val="8EA0B8"/>
@@ -7344,6 +7380,7 @@
           <a:lstStyle xmlns:a="http://schemas.openxmlformats.org/drawingml/2006/main"/>
           <a:p xmlns:a="http://schemas.openxmlformats.org/drawingml/2006/main">
             <a:pPr algn="ctr">
+              <a:buNone/>
               <a:defRPr sz="3900" b="1">
                 <a:solidFill>
                   <a:srgbClr val="65B7FF"/>
@@ -7394,6 +7431,7 @@
           <a:lstStyle xmlns:a="http://schemas.openxmlformats.org/drawingml/2006/main"/>
           <a:p xmlns:a="http://schemas.openxmlformats.org/drawingml/2006/main">
             <a:pPr algn="ctr">
+              <a:buNone/>
               <a:defRPr sz="1575" b="1">
                 <a:solidFill>
                   <a:srgbClr val="F5F8FC"/>
@@ -7444,6 +7482,7 @@
           <a:lstStyle xmlns:a="http://schemas.openxmlformats.org/drawingml/2006/main"/>
           <a:p xmlns:a="http://schemas.openxmlformats.org/drawingml/2006/main">
             <a:pPr algn="ctr">
+              <a:buNone/>
               <a:defRPr sz="1050" b="1">
                 <a:solidFill>
                   <a:srgbClr val="8EA0B8"/>
@@ -7527,6 +7566,7 @@
           <a:lstStyle xmlns:a="http://schemas.openxmlformats.org/drawingml/2006/main"/>
           <a:p xmlns:a="http://schemas.openxmlformats.org/drawingml/2006/main">
             <a:pPr algn="ctr">
+              <a:buNone/>
               <a:defRPr sz="2100" b="1">
                 <a:solidFill>
                   <a:srgbClr val="56D6A3"/>
@@ -7577,6 +7617,7 @@
           <a:lstStyle xmlns:a="http://schemas.openxmlformats.org/drawingml/2006/main"/>
           <a:p xmlns:a="http://schemas.openxmlformats.org/drawingml/2006/main">
             <a:pPr algn="ctr">
+              <a:buNone/>
               <a:defRPr sz="975" b="0">
                 <a:solidFill>
                   <a:srgbClr val="D3DEEA"/>
@@ -7627,6 +7668,7 @@
           <a:lstStyle xmlns:a="http://schemas.openxmlformats.org/drawingml/2006/main"/>
           <a:p xmlns:a="http://schemas.openxmlformats.org/drawingml/2006/main">
             <a:pPr algn="ctr">
+              <a:buNone/>
               <a:defRPr sz="2100" b="1">
                 <a:solidFill>
                   <a:srgbClr val="FF7B92"/>
@@ -7677,6 +7719,7 @@
           <a:lstStyle xmlns:a="http://schemas.openxmlformats.org/drawingml/2006/main"/>
           <a:p xmlns:a="http://schemas.openxmlformats.org/drawingml/2006/main">
             <a:pPr algn="ctr">
+              <a:buNone/>
               <a:defRPr sz="975" b="0">
                 <a:solidFill>
                   <a:srgbClr val="D3DEEA"/>
@@ -7727,6 +7770,7 @@
           <a:lstStyle xmlns:a="http://schemas.openxmlformats.org/drawingml/2006/main"/>
           <a:p xmlns:a="http://schemas.openxmlformats.org/drawingml/2006/main">
             <a:pPr algn="ctr">
+              <a:buNone/>
               <a:defRPr sz="2100" b="1">
                 <a:solidFill>
                   <a:srgbClr val="FFCB6B"/>
@@ -7777,6 +7821,7 @@
           <a:lstStyle xmlns:a="http://schemas.openxmlformats.org/drawingml/2006/main"/>
           <a:p xmlns:a="http://schemas.openxmlformats.org/drawingml/2006/main">
             <a:pPr algn="ctr">
+              <a:buNone/>
               <a:defRPr sz="975" b="0">
                 <a:solidFill>
                   <a:srgbClr val="D3DEEA"/>
@@ -7860,6 +7905,7 @@
           <a:lstStyle xmlns:a="http://schemas.openxmlformats.org/drawingml/2006/main"/>
           <a:p xmlns:a="http://schemas.openxmlformats.org/drawingml/2006/main">
             <a:pPr algn="l">
+              <a:buNone/>
               <a:defRPr sz="750" b="1">
                 <a:solidFill>
                   <a:srgbClr val="B69DF8"/>
@@ -7910,6 +7956,7 @@
           <a:lstStyle xmlns:a="http://schemas.openxmlformats.org/drawingml/2006/main"/>
           <a:p xmlns:a="http://schemas.openxmlformats.org/drawingml/2006/main">
             <a:pPr algn="l">
+              <a:buNone/>
               <a:defRPr sz="1125" b="0">
                 <a:solidFill>
                   <a:srgbClr val="F5F8FC"/>
@@ -7991,6 +8038,7 @@
           <a:lstStyle xmlns:a="http://schemas.openxmlformats.org/drawingml/2006/main"/>
           <a:p xmlns:a="http://schemas.openxmlformats.org/drawingml/2006/main">
             <a:pPr algn="l">
+              <a:buNone/>
               <a:defRPr sz="750" b="1">
                 <a:solidFill>
                   <a:srgbClr val="8EA0B8"/>
@@ -8041,6 +8089,7 @@
           <a:lstStyle xmlns:a="http://schemas.openxmlformats.org/drawingml/2006/main"/>
           <a:p xmlns:a="http://schemas.openxmlformats.org/drawingml/2006/main">
             <a:pPr algn="l">
+              <a:buNone/>
               <a:defRPr sz="1275" b="1">
                 <a:solidFill>
                   <a:srgbClr val="56D6A3"/>
@@ -8091,6 +8140,7 @@
           <a:lstStyle xmlns:a="http://schemas.openxmlformats.org/drawingml/2006/main"/>
           <a:p xmlns:a="http://schemas.openxmlformats.org/drawingml/2006/main">
             <a:pPr algn="l">
+              <a:buNone/>
               <a:defRPr sz="750" b="1">
                 <a:solidFill>
                   <a:srgbClr val="8EA0B8"/>
@@ -8141,6 +8191,7 @@
           <a:lstStyle xmlns:a="http://schemas.openxmlformats.org/drawingml/2006/main"/>
           <a:p xmlns:a="http://schemas.openxmlformats.org/drawingml/2006/main">
             <a:pPr algn="l">
+              <a:buNone/>
               <a:defRPr sz="1275" b="1">
                 <a:solidFill>
                   <a:srgbClr val="65B7FF"/>
@@ -8191,6 +8242,7 @@
           <a:lstStyle xmlns:a="http://schemas.openxmlformats.org/drawingml/2006/main"/>
           <a:p xmlns:a="http://schemas.openxmlformats.org/drawingml/2006/main">
             <a:pPr algn="l">
+              <a:buNone/>
               <a:defRPr sz="750" b="1">
                 <a:solidFill>
                   <a:srgbClr val="8EA0B8"/>
@@ -8241,6 +8293,7 @@
           <a:lstStyle xmlns:a="http://schemas.openxmlformats.org/drawingml/2006/main"/>
           <a:p xmlns:a="http://schemas.openxmlformats.org/drawingml/2006/main">
             <a:pPr algn="l">
+              <a:buNone/>
               <a:defRPr sz="1275" b="1">
                 <a:solidFill>
                   <a:srgbClr val="B69DF8"/>
@@ -8291,6 +8344,7 @@
           <a:lstStyle xmlns:a="http://schemas.openxmlformats.org/drawingml/2006/main"/>
           <a:p xmlns:a="http://schemas.openxmlformats.org/drawingml/2006/main">
             <a:pPr algn="l">
+              <a:buNone/>
               <a:defRPr sz="750" b="1">
                 <a:solidFill>
                   <a:srgbClr val="8EA0B8"/>
@@ -8341,6 +8395,7 @@
           <a:lstStyle xmlns:a="http://schemas.openxmlformats.org/drawingml/2006/main"/>
           <a:p xmlns:a="http://schemas.openxmlformats.org/drawingml/2006/main">
             <a:pPr algn="l">
+              <a:buNone/>
               <a:defRPr sz="1125" b="1">
                 <a:solidFill>
                   <a:srgbClr val="FFCB6B"/>
@@ -9986,7 +10041,7 @@
                   <a:srgbClr val="8EA0B8"/>
                 </a:solidFill>
               </a:rPr>
-              <a:t>AWS PUBLIC CHANGE ALERTING</a:t>
+              <a:t>© 2026 LILA BROOKS · APACHE-2.0</a:t>
             </a:r>
           </a:p>
         </p:txBody>
@@ -11558,7 +11613,7 @@
                   <a:srgbClr val="8EA0B8"/>
                 </a:solidFill>
               </a:rPr>
-              <a:t>AWS PUBLIC CHANGE ALERTING</a:t>
+              <a:t>© 2026 LILA BROOKS · APACHE-2.0</a:t>
             </a:r>
           </a:p>
         </p:txBody>
@@ -11789,7 +11844,7 @@
           <p:nvPr/>
         </p:nvPicPr>
         <p:blipFill>
-          <a:blip xmlns:r="http://schemas.openxmlformats.org/officeDocument/2006/relationships" xmlns:a="http://schemas.openxmlformats.org/drawingml/2006/main" r:embed="R9efd2ddc9546426a"/>
+          <a:blip xmlns:r="http://schemas.openxmlformats.org/officeDocument/2006/relationships" xmlns:a="http://schemas.openxmlformats.org/drawingml/2006/main" r:embed="Ra88c3f8db3994aa7"/>
           <a:stretch xmlns:a="http://schemas.openxmlformats.org/drawingml/2006/main"/>
         </p:blipFill>
         <p:spPr>
@@ -12269,7 +12324,7 @@
                   <a:srgbClr val="8EA0B8"/>
                 </a:solidFill>
               </a:rPr>
-              <a:t>AWS PUBLIC CHANGE ALERTING</a:t>
+              <a:t>© 2026 LILA BROOKS · APACHE-2.0</a:t>
             </a:r>
           </a:p>
         </p:txBody>
@@ -13619,7 +13674,7 @@
                   <a:srgbClr val="8EA0B8"/>
                 </a:solidFill>
               </a:rPr>
-              <a:t>Status source: README project table · accepted ADR-024</a:t>
+              <a:t>Status source: README project table · accepted ADR-024 · github.com/lilabrooks/aws-public-change-feed</a:t>
             </a:r>
           </a:p>
         </p:txBody>
@@ -13670,7 +13725,7 @@
                   <a:srgbClr val="8EA0B8"/>
                 </a:solidFill>
               </a:rPr>
-              <a:t>AWS PUBLIC CHANGE ALERTING</a:t>
+              <a:t>© 2026 LILA BROOKS · APACHE-2.0</a:t>
             </a:r>
           </a:p>
         </p:txBody>

</xml_diff>

<commit_message>
docs: replace abstract MVP language with concrete system behavior
Update the README, site, diagram, walkthrough, video, captions, deck, PDF, and governing prose to name the matched fields, AWS services, delivery states, and recorded results directly.\n\nThis is a documentation, site, and media change only. It does not change matcher configuration, runtime behavior, contracts, trust boundaries, or delivery guarantees, so no ADR or application-package rebuild is required. The corpus evaluator still reports 1.000 precision and 1.000 recall.
</commit_message>
<xml_diff>
--- a/site/media/mvp-evidence-v2/aws-public-change-alerting-mvp-evidence-v2.pptx
+++ b/site/media/mvp-evidence-v2/aws-public-change-alerting-mvp-evidence-v2.pptx
@@ -2,21 +2,21 @@
 <file path=ppt/presentation.xml><?xml version="1.0" encoding="utf-8"?>
 <p:presentation xmlns:p="http://schemas.openxmlformats.org/presentationml/2006/main">
   <p:sldMasterIdLst>
-    <p:sldMasterId xmlns:r="http://schemas.openxmlformats.org/officeDocument/2006/relationships" id="2147483648" r:id="R2d7f09c4e3494a48"/>
+    <p:sldMasterId xmlns:r="http://schemas.openxmlformats.org/officeDocument/2006/relationships" id="2147483648" r:id="Rda5e8d844d934cb7"/>
   </p:sldMasterIdLst>
   <p:notesMasterIdLst>
-    <p:notesMasterId xmlns:r="http://schemas.openxmlformats.org/officeDocument/2006/relationships" r:id="Rd6a2128376c04d2e"/>
+    <p:notesMasterId xmlns:r="http://schemas.openxmlformats.org/officeDocument/2006/relationships" r:id="R7f7a4e164fc040c5"/>
   </p:notesMasterIdLst>
   <p:sldIdLst>
-    <p:sldId xmlns:r="http://schemas.openxmlformats.org/officeDocument/2006/relationships" id="256" r:id="R86bc252a80ab45b5"/>
-    <p:sldId xmlns:r="http://schemas.openxmlformats.org/officeDocument/2006/relationships" id="257" r:id="R19defab6a4ce4221"/>
-    <p:sldId xmlns:r="http://schemas.openxmlformats.org/officeDocument/2006/relationships" id="258" r:id="R964386c313524c2c"/>
-    <p:sldId xmlns:r="http://schemas.openxmlformats.org/officeDocument/2006/relationships" id="259" r:id="R4738dadd04fa4e05"/>
-    <p:sldId xmlns:r="http://schemas.openxmlformats.org/officeDocument/2006/relationships" id="260" r:id="R5f2e918bdef945e3"/>
-    <p:sldId xmlns:r="http://schemas.openxmlformats.org/officeDocument/2006/relationships" id="261" r:id="R7eafab6110e748fa"/>
-    <p:sldId xmlns:r="http://schemas.openxmlformats.org/officeDocument/2006/relationships" id="262" r:id="Rfb3b8794f91b4f77"/>
-    <p:sldId xmlns:r="http://schemas.openxmlformats.org/officeDocument/2006/relationships" id="263" r:id="R79ac96b7c3b741f9"/>
-    <p:sldId xmlns:r="http://schemas.openxmlformats.org/officeDocument/2006/relationships" id="264" r:id="R0c2aa4df89124235"/>
+    <p:sldId xmlns:r="http://schemas.openxmlformats.org/officeDocument/2006/relationships" id="256" r:id="Rad366f2703ac492f"/>
+    <p:sldId xmlns:r="http://schemas.openxmlformats.org/officeDocument/2006/relationships" id="257" r:id="Red051041dfd94bb5"/>
+    <p:sldId xmlns:r="http://schemas.openxmlformats.org/officeDocument/2006/relationships" id="258" r:id="R91f7d242d95e4e10"/>
+    <p:sldId xmlns:r="http://schemas.openxmlformats.org/officeDocument/2006/relationships" id="259" r:id="R9f6a8e28c1c447af"/>
+    <p:sldId xmlns:r="http://schemas.openxmlformats.org/officeDocument/2006/relationships" id="260" r:id="Rd0b1c2433a4a4e24"/>
+    <p:sldId xmlns:r="http://schemas.openxmlformats.org/officeDocument/2006/relationships" id="261" r:id="R2f99a024e3f94b51"/>
+    <p:sldId xmlns:r="http://schemas.openxmlformats.org/officeDocument/2006/relationships" id="262" r:id="R853fa5d01df04388"/>
+    <p:sldId xmlns:r="http://schemas.openxmlformats.org/officeDocument/2006/relationships" id="263" r:id="Rcf03af1206684bfa"/>
+    <p:sldId xmlns:r="http://schemas.openxmlformats.org/officeDocument/2006/relationships" id="264" r:id="R2e7fdb16add147e4"/>
   </p:sldIdLst>
   <p:sldSz cx="12192000" cy="6858000"/>
   <p:notesSz cx="6858000" cy="9144000"/>
@@ -450,7 +450,7 @@
           <a:lstStyle xmlns:a="http://schemas.openxmlformats.org/drawingml/2006/main"/>
           <a:p xmlns:a="http://schemas.openxmlformats.org/drawingml/2006/main">
             <a:r>
-              <a:t>This is AWS Public Change Alerting. I built it to turn public AWS announcements into a short, explainable review feed for the teams that use the affected services. This is the dev MVP evidence pack, captured after the first milestone closed.</a:t>
+              <a:t>This is AWS Public Change Alerting. I built it to match public AWS announcements against configured services and risk phrases, map each result to a Slack route, and deliver it through DynamoDB and SQS. This walkthrough records the dev MVP after the first milestone closed.</a:t>
             </a:r>
           </a:p>
           <a:p xmlns:a="http://schemas.openxmlformats.org/drawingml/2006/main">
@@ -465,12 +465,12 @@
           </a:p>
           <a:p xmlns:a="http://schemas.openxmlformats.org/drawingml/2006/main">
             <a:r>
-              <a:t>- /Users/lilabrooks/Documents/aws-public-change-feed/README.md:18-29</a:t>
-            </a:r>
-          </a:p>
-          <a:p xmlns:a="http://schemas.openxmlformats.org/drawingml/2006/main">
-            <a:r>
-              <a:t>- /Users/lilabrooks/Documents/aws-public-change-feed/docs/GOAL.md:1-35</a:t>
+              <a:t>- /Users/lilabrooks/Documents/aws-public-change-feed/README.md</a:t>
+            </a:r>
+          </a:p>
+          <a:p xmlns:a="http://schemas.openxmlformats.org/drawingml/2006/main">
+            <a:r>
+              <a:t>- /Users/lilabrooks/Documents/aws-public-change-feed/docs/GOAL.md</a:t>
             </a:r>
           </a:p>
         </p:txBody>
@@ -540,7 +540,7 @@
           <a:lstStyle xmlns:a="http://schemas.openxmlformats.org/drawingml/2006/main"/>
           <a:p xmlns:a="http://schemas.openxmlformats.org/drawingml/2006/main">
             <a:r>
-              <a:t>Here’s the whole trip. A watcher reads approved RSS and Atom feeds, saves the raw response, and works out which service and risk rule fired. The candidate is tied to configured environments, then written to DynamoDB. SQS carries the delivery request to Slack, and the result comes back to the same durable record.</a:t>
+              <a:t>Here’s the whole trip. A watcher reads approved RSS and Atom feeds, saves the raw response, and works out which service and risk rule fired. The candidate is tied to configured environments, then written to DynamoDB. SQS carries the delivery request to Slack, and the result comes back to the same DynamoDB delivery record.</a:t>
             </a:r>
           </a:p>
           <a:p xmlns:a="http://schemas.openxmlformats.org/drawingml/2006/main">
@@ -565,7 +565,7 @@
           </a:p>
           <a:p xmlns:a="http://schemas.openxmlformats.org/drawingml/2006/main">
             <a:r>
-              <a:t>- /Users/lilabrooks/Documents/aws-public-change-feed/README.md:31-40</a:t>
+              <a:t>- /Users/lilabrooks/Documents/aws-public-change-feed/README.md</a:t>
             </a:r>
           </a:p>
         </p:txBody>
@@ -650,17 +650,17 @@
           </a:p>
           <a:p xmlns:a="http://schemas.openxmlformats.org/drawingml/2006/main">
             <a:r>
-              <a:t>- /Users/lilabrooks/Documents/aws-public-change-feed/README.md:22-29</a:t>
-            </a:r>
-          </a:p>
-          <a:p xmlns:a="http://schemas.openxmlformats.org/drawingml/2006/main">
-            <a:r>
-              <a:t>- /Users/lilabrooks/Documents/aws-public-change-feed/docs/architecture/specification/01-overview.md:37-66</a:t>
-            </a:r>
-          </a:p>
-          <a:p xmlns:a="http://schemas.openxmlformats.org/drawingml/2006/main">
-            <a:r>
-              <a:t>- /Users/lilabrooks/Documents/aws-public-change-feed/docs/architecture/specification/05-security-and-operations.md:99-166</a:t>
+              <a:t>- /Users/lilabrooks/Documents/aws-public-change-feed/README.md</a:t>
+            </a:r>
+          </a:p>
+          <a:p xmlns:a="http://schemas.openxmlformats.org/drawingml/2006/main">
+            <a:r>
+              <a:t>- /Users/lilabrooks/Documents/aws-public-change-feed/docs/architecture/specification/01-overview.md</a:t>
+            </a:r>
+          </a:p>
+          <a:p xmlns:a="http://schemas.openxmlformats.org/drawingml/2006/main">
+            <a:r>
+              <a:t>- /Users/lilabrooks/Documents/aws-public-change-feed/docs/architecture/specification/05-security-and-operations.md</a:t>
             </a:r>
           </a:p>
         </p:txBody>
@@ -835,7 +835,7 @@
           <a:lstStyle xmlns:a="http://schemas.openxmlformats.org/drawingml/2006/main"/>
           <a:p xmlns:a="http://schemas.openxmlformats.org/drawingml/2006/main">
             <a:r>
-              <a:t>Delivery only matters if the matcher is worth listening to. The current corpus has forty-seven labeled announcements: thirty-two historical and fifteen synthetic. This run produced twenty-nine true-positive service and risk pairs with zero false positives and zero false negatives. The global gate passes. A few pairs are still thin, so I’ve kept that limit visible.</a:t>
+              <a:t>Delivery only matters if the matcher is worth listening to. The current corpus has forty-seven labeled announcements: thirty-two historical and fifteen synthetic. This run produced twenty-nine true-positive service and risk pairs with zero false positives and zero false negatives. The global gate passes. Four of ten pairs still have only one or two positive examples, so that limit stays visible.</a:t>
             </a:r>
           </a:p>
           <a:p xmlns:a="http://schemas.openxmlformats.org/drawingml/2006/main">
@@ -955,7 +955,7 @@
           </a:p>
           <a:p xmlns:a="http://schemas.openxmlformats.org/drawingml/2006/main">
             <a:r>
-              <a:t>- /Users/lilabrooks/Documents/aws-public-change-feed/docs/architecture/specification/04-alert-processing.md:107-150</a:t>
+              <a:t>- /Users/lilabrooks/Documents/aws-public-change-feed/docs/architecture/specification/04-alert-processing.md</a:t>
             </a:r>
           </a:p>
           <a:p xmlns:a="http://schemas.openxmlformats.org/drawingml/2006/main">
@@ -1030,7 +1030,7 @@
           <a:lstStyle xmlns:a="http://schemas.openxmlformats.org/drawingml/2006/main"/>
           <a:p xmlns:a="http://schemas.openxmlformats.org/drawingml/2006/main">
             <a:r>
-              <a:t>That identity stays with the delivery request. The dispatcher moves it from pending to queued. The worker claims a lease, makes the Slack call, and writes the outcome. A documented success becomes posted. An ambiguous result stays delivery unknown for an operator to examine.</a:t>
+              <a:t>That identity stays with the delivery request. The dispatcher moves it from pending to queued. The worker claims a lease, makes the Slack call, and writes the outcome. When Slack returns a success response, the worker writes posted. An ambiguous result stays delivery unknown for an operator to examine.</a:t>
             </a:r>
           </a:p>
           <a:p xmlns:a="http://schemas.openxmlformats.org/drawingml/2006/main">
@@ -1050,12 +1050,12 @@
           </a:p>
           <a:p xmlns:a="http://schemas.openxmlformats.org/drawingml/2006/main">
             <a:r>
-              <a:t>- /Users/lilabrooks/Documents/aws-public-change-feed/docs/architecture/specification/02-platform.md:38-74</a:t>
-            </a:r>
-          </a:p>
-          <a:p xmlns:a="http://schemas.openxmlformats.org/drawingml/2006/main">
-            <a:r>
-              <a:t>- /Users/lilabrooks/Documents/aws-public-change-feed/docs/architecture/specification/04-alert-processing.md:136-188</a:t>
+              <a:t>- /Users/lilabrooks/Documents/aws-public-change-feed/docs/architecture/specification/02-platform.md</a:t>
+            </a:r>
+          </a:p>
+          <a:p xmlns:a="http://schemas.openxmlformats.org/drawingml/2006/main">
+            <a:r>
+              <a:t>- /Users/lilabrooks/Documents/aws-public-change-feed/docs/architecture/specification/04-alert-processing.md</a:t>
             </a:r>
           </a:p>
         </p:txBody>
@@ -1140,17 +1140,17 @@
           </a:p>
           <a:p xmlns:a="http://schemas.openxmlformats.org/drawingml/2006/main">
             <a:r>
-              <a:t>- /Users/lilabrooks/Documents/aws-public-change-feed/site/index.html:321-356</a:t>
-            </a:r>
-          </a:p>
-          <a:p xmlns:a="http://schemas.openxmlformats.org/drawingml/2006/main">
-            <a:r>
-              <a:t>- /Users/lilabrooks/Documents/aws-public-change-feed/docs/adr/024-isolated-live-runtime-exercises.md:10-15</a:t>
-            </a:r>
-          </a:p>
-          <a:p xmlns:a="http://schemas.openxmlformats.org/drawingml/2006/main">
-            <a:r>
-              <a:t>- /Users/lilabrooks/Documents/aws-public-change-feed/README.md:20-29</a:t>
+              <a:t>- /Users/lilabrooks/Documents/aws-public-change-feed/site/index.html</a:t>
+            </a:r>
+          </a:p>
+          <a:p xmlns:a="http://schemas.openxmlformats.org/drawingml/2006/main">
+            <a:r>
+              <a:t>- /Users/lilabrooks/Documents/aws-public-change-feed/docs/adr/024-isolated-live-runtime-exercises.md</a:t>
+            </a:r>
+          </a:p>
+          <a:p xmlns:a="http://schemas.openxmlformats.org/drawingml/2006/main">
+            <a:r>
+              <a:t>- /Users/lilabrooks/Documents/aws-public-change-feed/README.md</a:t>
             </a:r>
           </a:p>
         </p:txBody>
@@ -1220,7 +1220,7 @@
           <a:lstStyle xmlns:a="http://schemas.openxmlformats.org/drawingml/2006/main"/>
           <a:p xmlns:a="http://schemas.openxmlformats.org/drawingml/2006/main">
             <a:r>
-              <a:t>So, what closed the milestone? Four runtime triggers were enabled. Twelve public-feed posts reached Slack. Both recovery cases passed. The isolated load run created fifty messages at five per minute, and the alarm email arrived. That gives the dev MVP executable evidence. Production readiness stays a later gate.</a:t>
+              <a:t>So, what closed the milestone? Four runtime triggers were enabled. Twelve public-feed posts reached Slack. Both recovery cases passed. The isolated load run created fifty messages at five per minute, and the alarm email arrived. Those Slack, recovery, load, and alarm results close the dev MVP. Production readiness stays a later gate.</a:t>
             </a:r>
           </a:p>
           <a:p xmlns:a="http://schemas.openxmlformats.org/drawingml/2006/main">
@@ -1235,7 +1235,7 @@
           </a:p>
           <a:p xmlns:a="http://schemas.openxmlformats.org/drawingml/2006/main">
             <a:r>
-              <a:t>- /Users/lilabrooks/Documents/aws-public-change-feed/README.md:18-29</a:t>
+              <a:t>- /Users/lilabrooks/Documents/aws-public-change-feed/README.md</a:t>
             </a:r>
           </a:p>
           <a:p xmlns:a="http://schemas.openxmlformats.org/drawingml/2006/main">
@@ -1245,7 +1245,7 @@
           </a:p>
           <a:p xmlns:a="http://schemas.openxmlformats.org/drawingml/2006/main">
             <a:r>
-              <a:t>- /Users/lilabrooks/Documents/aws-public-change-feed/docs/architecture/specification/06-acceptance-and-generation.md:201-225</a:t>
+              <a:t>- /Users/lilabrooks/Documents/aws-public-change-feed/docs/architecture/specification/06-acceptance-and-generation.md</a:t>
             </a:r>
           </a:p>
         </p:txBody>
@@ -1313,7 +1313,7 @@
   </p:cSld>
   <p:clrMap bg1="lt1" tx1="dk1" bg2="lt2" tx2="dk2" accent1="accent1" accent2="accent2" accent3="accent3" accent4="accent4" accent5="accent5" accent6="accent6" hlink="hlink" folHlink="folHlink"/>
   <p:sldLayoutIdLst>
-    <p:sldLayoutId xmlns:r="http://schemas.openxmlformats.org/officeDocument/2006/relationships" id="2147483649" r:id="R62792ef662e34255"/>
+    <p:sldLayoutId xmlns:r="http://schemas.openxmlformats.org/officeDocument/2006/relationships" id="2147483649" r:id="Rb6cf7d8b5ff243f5"/>
   </p:sldLayoutIdLst>
   <p:txStyles>
     <p:titleStyle>
@@ -1905,7 +1905,7 @@
                   <a:srgbClr val="65B7FF"/>
                 </a:solidFill>
               </a:rPr>
-              <a:t>DEV MVP EVIDENCE</a:t>
+              <a:t>DEV MVP RESULTS</a:t>
             </a:r>
           </a:p>
         </p:txBody>
@@ -2025,7 +2025,7 @@
                   <a:srgbClr val="D3DEEA"/>
                 </a:solidFill>
               </a:rPr>
-              <a:t>Public AWS feeds become explainable, route-scoped review candidates and reach Slack through a durable AWS delivery path.</a:t>
+              <a:t>Public AWS announcements are matched against configured services and risk phrases, mapped to Slack routes, stored in DynamoDB, and delivered through SQS.</a:t>
             </a:r>
           </a:p>
         </p:txBody>
@@ -2107,7 +2107,7 @@
                   <a:srgbClr val="8EA0B8"/>
                 </a:solidFill>
               </a:rPr>
-              <a:t>EVIDENCE WINDOW</a:t>
+              <a:t>RECORDED RUN</a:t>
             </a:r>
           </a:p>
         </p:txBody>
@@ -2419,7 +2419,7 @@
                   <a:srgbClr val="8EA0B8"/>
                 </a:solidFill>
               </a:rPr>
-              <a:t>Repository evidence · public edition</a:t>
+              <a:t>Repository results · public edition</a:t>
             </a:r>
           </a:p>
         </p:txBody>
@@ -2701,11 +2701,11 @@
           <p:nvPr/>
         </p:nvPicPr>
         <p:blipFill>
-          <a:blip xmlns:r="http://schemas.openxmlformats.org/officeDocument/2006/relationships" xmlns:a="http://schemas.openxmlformats.org/drawingml/2006/main" r:embed="Rda1755c2387849b3"/>
+          <a:blip xmlns:r="http://schemas.openxmlformats.org/officeDocument/2006/relationships" xmlns:a="http://schemas.openxmlformats.org/drawingml/2006/main" r:embed="R9c1b77da01e3412c"/>
           <a:stretch xmlns:a="http://schemas.openxmlformats.org/drawingml/2006/main"/>
         </p:blipFill>
         <p:spPr>
-          <a:xfrm xmlns:a="http://schemas.openxmlformats.org/drawingml/2006/main">
+          <a:xfrm xmlns:a="http://schemas.openxmlformats.org/drawingml/2006/main" flipH="0" flipV="0">
             <a:off x="1128346" y="1466850"/>
             <a:ext cx="9935308" cy="4305300"/>
           </a:xfrm>
@@ -4192,7 +4192,7 @@
                   <a:srgbClr val="8EA0B8"/>
                 </a:solidFill>
               </a:rPr>
-              <a:t>TRIGGER PROOF</a:t>
+              <a:t>ENABLED TRIGGERS</a:t>
             </a:r>
           </a:p>
         </p:txBody>
@@ -4294,7 +4294,7 @@
                   <a:srgbClr val="8EA0B8"/>
                 </a:solidFill>
               </a:rPr>
-              <a:t>PACKAGE BOUNDARY</a:t>
+              <a:t>PACKAGE DIGEST</a:t>
             </a:r>
           </a:p>
         </p:txBody>
@@ -4345,7 +4345,7 @@
                   <a:srgbClr val="65B7FF"/>
                 </a:solidFill>
               </a:rPr>
-              <a:t>exact shared bytes</a:t>
+              <a:t>same SHA-256 digest</a:t>
             </a:r>
           </a:p>
         </p:txBody>
@@ -5363,7 +5363,7 @@
                   <a:srgbClr val="D3DEEA"/>
                 </a:solidFill>
               </a:rPr>
-              <a:t>Scoped concurrency evidence</a:t>
+              <a:t>Scoped S3 test identity</a:t>
             </a:r>
           </a:p>
         </p:txBody>
@@ -7969,7 +7969,7 @@
                   <a:srgbClr val="F5F8FC"/>
                 </a:solidFill>
               </a:rPr>
-              <a:t>4 of 10 service/risk pairs have only 1-2 positives. More historical examples are the next evidence need.</a:t>
+              <a:t>4 of 10 service/risk pairs have only 1–2 positives. More labeled historical examples are needed.</a:t>
             </a:r>
           </a:p>
         </p:txBody>
@@ -10121,7 +10121,7 @@
                   <a:srgbClr val="65B7FF"/>
                 </a:solidFill>
               </a:rPr>
-              <a:t>DURABLE DELIVERY</a:t>
+              <a:t>DELIVERY STATE</a:t>
             </a:r>
           </a:p>
         </p:txBody>
@@ -10904,7 +10904,7 @@
                   <a:srgbClr val="D3DEEA"/>
                 </a:solidFill>
               </a:rPr>
-              <a:t>documented success</a:t>
+              <a:t>Slack success response</a:t>
             </a:r>
           </a:p>
         </p:txBody>
@@ -11693,7 +11693,7 @@
                   <a:srgbClr val="65B7FF"/>
                 </a:solidFill>
               </a:rPr>
-              <a:t>DELIVERY EVIDENCE</a:t>
+              <a:t>RECORDED DELIVERY RESULT</a:t>
             </a:r>
           </a:p>
         </p:txBody>
@@ -11844,7 +11844,7 @@
           <p:nvPr/>
         </p:nvPicPr>
         <p:blipFill>
-          <a:blip xmlns:r="http://schemas.openxmlformats.org/officeDocument/2006/relationships" xmlns:a="http://schemas.openxmlformats.org/drawingml/2006/main" r:embed="Ra88c3f8db3994aa7"/>
+          <a:blip xmlns:r="http://schemas.openxmlformats.org/officeDocument/2006/relationships" xmlns:a="http://schemas.openxmlformats.org/drawingml/2006/main" r:embed="R243dbe0b60d34469"/>
           <a:stretch xmlns:a="http://schemas.openxmlformats.org/drawingml/2006/main"/>
         </p:blipFill>
         <p:spPr>
@@ -12007,7 +12007,7 @@
                   <a:srgbClr val="F5F8FC"/>
                 </a:solidFill>
               </a:rPr>
-              <a:t>durable Slack posts</a:t>
+              <a:t>recorded Slack posts</a:t>
             </a:r>
           </a:p>
         </p:txBody>
@@ -12404,7 +12404,7 @@
                   <a:srgbClr val="65B7FF"/>
                 </a:solidFill>
               </a:rPr>
-              <a:t>WHAT THE MVP PROVED</a:t>
+              <a:t>RECORDED MVP RESULT</a:t>
             </a:r>
           </a:p>
         </p:txBody>
@@ -12455,7 +12455,7 @@
                   <a:srgbClr val="F5F8FC"/>
                 </a:solidFill>
               </a:rPr>
-              <a:t>M1 closed on live delivery and operational evidence</a:t>
+              <a:t>M1 closed on Slack, recovery, load, and alarm results</a:t>
             </a:r>
           </a:p>
         </p:txBody>
@@ -13592,7 +13592,7 @@
                   <a:srgbClr val="8EA0B8"/>
                 </a:solidFill>
               </a:rPr>
-              <a:t>The dev MVP has executable evidence. Production readiness remains an explicit later decision.</a:t>
+              <a:t>The Slack, recovery, load, and alarm results close the dev MVP. Production readiness remains a later decision.</a:t>
             </a:r>
           </a:p>
         </p:txBody>

</xml_diff>

<commit_message>
docs: replace abstract MVP language with concrete system behavior (#160)
Update the README, site, diagram, walkthrough, video, captions, deck, PDF, and governing prose to name the matched fields, AWS services, delivery states, and recorded results directly.\n\nThis is a documentation, site, and media change only. It does not change matcher configuration, runtime behavior, contracts, trust boundaries, or delivery guarantees, so no ADR or application-package rebuild is required. The corpus evaluator still reports 1.000 precision and 1.000 recall.
</commit_message>
<xml_diff>
--- a/site/media/mvp-evidence-v2/aws-public-change-alerting-mvp-evidence-v2.pptx
+++ b/site/media/mvp-evidence-v2/aws-public-change-alerting-mvp-evidence-v2.pptx
@@ -2,21 +2,21 @@
 <file path=ppt/presentation.xml><?xml version="1.0" encoding="utf-8"?>
 <p:presentation xmlns:p="http://schemas.openxmlformats.org/presentationml/2006/main">
   <p:sldMasterIdLst>
-    <p:sldMasterId xmlns:r="http://schemas.openxmlformats.org/officeDocument/2006/relationships" id="2147483648" r:id="R2d7f09c4e3494a48"/>
+    <p:sldMasterId xmlns:r="http://schemas.openxmlformats.org/officeDocument/2006/relationships" id="2147483648" r:id="Rda5e8d844d934cb7"/>
   </p:sldMasterIdLst>
   <p:notesMasterIdLst>
-    <p:notesMasterId xmlns:r="http://schemas.openxmlformats.org/officeDocument/2006/relationships" r:id="Rd6a2128376c04d2e"/>
+    <p:notesMasterId xmlns:r="http://schemas.openxmlformats.org/officeDocument/2006/relationships" r:id="R7f7a4e164fc040c5"/>
   </p:notesMasterIdLst>
   <p:sldIdLst>
-    <p:sldId xmlns:r="http://schemas.openxmlformats.org/officeDocument/2006/relationships" id="256" r:id="R86bc252a80ab45b5"/>
-    <p:sldId xmlns:r="http://schemas.openxmlformats.org/officeDocument/2006/relationships" id="257" r:id="R19defab6a4ce4221"/>
-    <p:sldId xmlns:r="http://schemas.openxmlformats.org/officeDocument/2006/relationships" id="258" r:id="R964386c313524c2c"/>
-    <p:sldId xmlns:r="http://schemas.openxmlformats.org/officeDocument/2006/relationships" id="259" r:id="R4738dadd04fa4e05"/>
-    <p:sldId xmlns:r="http://schemas.openxmlformats.org/officeDocument/2006/relationships" id="260" r:id="R5f2e918bdef945e3"/>
-    <p:sldId xmlns:r="http://schemas.openxmlformats.org/officeDocument/2006/relationships" id="261" r:id="R7eafab6110e748fa"/>
-    <p:sldId xmlns:r="http://schemas.openxmlformats.org/officeDocument/2006/relationships" id="262" r:id="Rfb3b8794f91b4f77"/>
-    <p:sldId xmlns:r="http://schemas.openxmlformats.org/officeDocument/2006/relationships" id="263" r:id="R79ac96b7c3b741f9"/>
-    <p:sldId xmlns:r="http://schemas.openxmlformats.org/officeDocument/2006/relationships" id="264" r:id="R0c2aa4df89124235"/>
+    <p:sldId xmlns:r="http://schemas.openxmlformats.org/officeDocument/2006/relationships" id="256" r:id="Rad366f2703ac492f"/>
+    <p:sldId xmlns:r="http://schemas.openxmlformats.org/officeDocument/2006/relationships" id="257" r:id="Red051041dfd94bb5"/>
+    <p:sldId xmlns:r="http://schemas.openxmlformats.org/officeDocument/2006/relationships" id="258" r:id="R91f7d242d95e4e10"/>
+    <p:sldId xmlns:r="http://schemas.openxmlformats.org/officeDocument/2006/relationships" id="259" r:id="R9f6a8e28c1c447af"/>
+    <p:sldId xmlns:r="http://schemas.openxmlformats.org/officeDocument/2006/relationships" id="260" r:id="Rd0b1c2433a4a4e24"/>
+    <p:sldId xmlns:r="http://schemas.openxmlformats.org/officeDocument/2006/relationships" id="261" r:id="R2f99a024e3f94b51"/>
+    <p:sldId xmlns:r="http://schemas.openxmlformats.org/officeDocument/2006/relationships" id="262" r:id="R853fa5d01df04388"/>
+    <p:sldId xmlns:r="http://schemas.openxmlformats.org/officeDocument/2006/relationships" id="263" r:id="Rcf03af1206684bfa"/>
+    <p:sldId xmlns:r="http://schemas.openxmlformats.org/officeDocument/2006/relationships" id="264" r:id="R2e7fdb16add147e4"/>
   </p:sldIdLst>
   <p:sldSz cx="12192000" cy="6858000"/>
   <p:notesSz cx="6858000" cy="9144000"/>
@@ -450,7 +450,7 @@
           <a:lstStyle xmlns:a="http://schemas.openxmlformats.org/drawingml/2006/main"/>
           <a:p xmlns:a="http://schemas.openxmlformats.org/drawingml/2006/main">
             <a:r>
-              <a:t>This is AWS Public Change Alerting. I built it to turn public AWS announcements into a short, explainable review feed for the teams that use the affected services. This is the dev MVP evidence pack, captured after the first milestone closed.</a:t>
+              <a:t>This is AWS Public Change Alerting. I built it to match public AWS announcements against configured services and risk phrases, map each result to a Slack route, and deliver it through DynamoDB and SQS. This walkthrough records the dev MVP after the first milestone closed.</a:t>
             </a:r>
           </a:p>
           <a:p xmlns:a="http://schemas.openxmlformats.org/drawingml/2006/main">
@@ -465,12 +465,12 @@
           </a:p>
           <a:p xmlns:a="http://schemas.openxmlformats.org/drawingml/2006/main">
             <a:r>
-              <a:t>- /Users/lilabrooks/Documents/aws-public-change-feed/README.md:18-29</a:t>
-            </a:r>
-          </a:p>
-          <a:p xmlns:a="http://schemas.openxmlformats.org/drawingml/2006/main">
-            <a:r>
-              <a:t>- /Users/lilabrooks/Documents/aws-public-change-feed/docs/GOAL.md:1-35</a:t>
+              <a:t>- /Users/lilabrooks/Documents/aws-public-change-feed/README.md</a:t>
+            </a:r>
+          </a:p>
+          <a:p xmlns:a="http://schemas.openxmlformats.org/drawingml/2006/main">
+            <a:r>
+              <a:t>- /Users/lilabrooks/Documents/aws-public-change-feed/docs/GOAL.md</a:t>
             </a:r>
           </a:p>
         </p:txBody>
@@ -540,7 +540,7 @@
           <a:lstStyle xmlns:a="http://schemas.openxmlformats.org/drawingml/2006/main"/>
           <a:p xmlns:a="http://schemas.openxmlformats.org/drawingml/2006/main">
             <a:r>
-              <a:t>Here’s the whole trip. A watcher reads approved RSS and Atom feeds, saves the raw response, and works out which service and risk rule fired. The candidate is tied to configured environments, then written to DynamoDB. SQS carries the delivery request to Slack, and the result comes back to the same durable record.</a:t>
+              <a:t>Here’s the whole trip. A watcher reads approved RSS and Atom feeds, saves the raw response, and works out which service and risk rule fired. The candidate is tied to configured environments, then written to DynamoDB. SQS carries the delivery request to Slack, and the result comes back to the same DynamoDB delivery record.</a:t>
             </a:r>
           </a:p>
           <a:p xmlns:a="http://schemas.openxmlformats.org/drawingml/2006/main">
@@ -565,7 +565,7 @@
           </a:p>
           <a:p xmlns:a="http://schemas.openxmlformats.org/drawingml/2006/main">
             <a:r>
-              <a:t>- /Users/lilabrooks/Documents/aws-public-change-feed/README.md:31-40</a:t>
+              <a:t>- /Users/lilabrooks/Documents/aws-public-change-feed/README.md</a:t>
             </a:r>
           </a:p>
         </p:txBody>
@@ -650,17 +650,17 @@
           </a:p>
           <a:p xmlns:a="http://schemas.openxmlformats.org/drawingml/2006/main">
             <a:r>
-              <a:t>- /Users/lilabrooks/Documents/aws-public-change-feed/README.md:22-29</a:t>
-            </a:r>
-          </a:p>
-          <a:p xmlns:a="http://schemas.openxmlformats.org/drawingml/2006/main">
-            <a:r>
-              <a:t>- /Users/lilabrooks/Documents/aws-public-change-feed/docs/architecture/specification/01-overview.md:37-66</a:t>
-            </a:r>
-          </a:p>
-          <a:p xmlns:a="http://schemas.openxmlformats.org/drawingml/2006/main">
-            <a:r>
-              <a:t>- /Users/lilabrooks/Documents/aws-public-change-feed/docs/architecture/specification/05-security-and-operations.md:99-166</a:t>
+              <a:t>- /Users/lilabrooks/Documents/aws-public-change-feed/README.md</a:t>
+            </a:r>
+          </a:p>
+          <a:p xmlns:a="http://schemas.openxmlformats.org/drawingml/2006/main">
+            <a:r>
+              <a:t>- /Users/lilabrooks/Documents/aws-public-change-feed/docs/architecture/specification/01-overview.md</a:t>
+            </a:r>
+          </a:p>
+          <a:p xmlns:a="http://schemas.openxmlformats.org/drawingml/2006/main">
+            <a:r>
+              <a:t>- /Users/lilabrooks/Documents/aws-public-change-feed/docs/architecture/specification/05-security-and-operations.md</a:t>
             </a:r>
           </a:p>
         </p:txBody>
@@ -835,7 +835,7 @@
           <a:lstStyle xmlns:a="http://schemas.openxmlformats.org/drawingml/2006/main"/>
           <a:p xmlns:a="http://schemas.openxmlformats.org/drawingml/2006/main">
             <a:r>
-              <a:t>Delivery only matters if the matcher is worth listening to. The current corpus has forty-seven labeled announcements: thirty-two historical and fifteen synthetic. This run produced twenty-nine true-positive service and risk pairs with zero false positives and zero false negatives. The global gate passes. A few pairs are still thin, so I’ve kept that limit visible.</a:t>
+              <a:t>Delivery only matters if the matcher is worth listening to. The current corpus has forty-seven labeled announcements: thirty-two historical and fifteen synthetic. This run produced twenty-nine true-positive service and risk pairs with zero false positives and zero false negatives. The global gate passes. Four of ten pairs still have only one or two positive examples, so that limit stays visible.</a:t>
             </a:r>
           </a:p>
           <a:p xmlns:a="http://schemas.openxmlformats.org/drawingml/2006/main">
@@ -955,7 +955,7 @@
           </a:p>
           <a:p xmlns:a="http://schemas.openxmlformats.org/drawingml/2006/main">
             <a:r>
-              <a:t>- /Users/lilabrooks/Documents/aws-public-change-feed/docs/architecture/specification/04-alert-processing.md:107-150</a:t>
+              <a:t>- /Users/lilabrooks/Documents/aws-public-change-feed/docs/architecture/specification/04-alert-processing.md</a:t>
             </a:r>
           </a:p>
           <a:p xmlns:a="http://schemas.openxmlformats.org/drawingml/2006/main">
@@ -1030,7 +1030,7 @@
           <a:lstStyle xmlns:a="http://schemas.openxmlformats.org/drawingml/2006/main"/>
           <a:p xmlns:a="http://schemas.openxmlformats.org/drawingml/2006/main">
             <a:r>
-              <a:t>That identity stays with the delivery request. The dispatcher moves it from pending to queued. The worker claims a lease, makes the Slack call, and writes the outcome. A documented success becomes posted. An ambiguous result stays delivery unknown for an operator to examine.</a:t>
+              <a:t>That identity stays with the delivery request. The dispatcher moves it from pending to queued. The worker claims a lease, makes the Slack call, and writes the outcome. When Slack returns a success response, the worker writes posted. An ambiguous result stays delivery unknown for an operator to examine.</a:t>
             </a:r>
           </a:p>
           <a:p xmlns:a="http://schemas.openxmlformats.org/drawingml/2006/main">
@@ -1050,12 +1050,12 @@
           </a:p>
           <a:p xmlns:a="http://schemas.openxmlformats.org/drawingml/2006/main">
             <a:r>
-              <a:t>- /Users/lilabrooks/Documents/aws-public-change-feed/docs/architecture/specification/02-platform.md:38-74</a:t>
-            </a:r>
-          </a:p>
-          <a:p xmlns:a="http://schemas.openxmlformats.org/drawingml/2006/main">
-            <a:r>
-              <a:t>- /Users/lilabrooks/Documents/aws-public-change-feed/docs/architecture/specification/04-alert-processing.md:136-188</a:t>
+              <a:t>- /Users/lilabrooks/Documents/aws-public-change-feed/docs/architecture/specification/02-platform.md</a:t>
+            </a:r>
+          </a:p>
+          <a:p xmlns:a="http://schemas.openxmlformats.org/drawingml/2006/main">
+            <a:r>
+              <a:t>- /Users/lilabrooks/Documents/aws-public-change-feed/docs/architecture/specification/04-alert-processing.md</a:t>
             </a:r>
           </a:p>
         </p:txBody>
@@ -1140,17 +1140,17 @@
           </a:p>
           <a:p xmlns:a="http://schemas.openxmlformats.org/drawingml/2006/main">
             <a:r>
-              <a:t>- /Users/lilabrooks/Documents/aws-public-change-feed/site/index.html:321-356</a:t>
-            </a:r>
-          </a:p>
-          <a:p xmlns:a="http://schemas.openxmlformats.org/drawingml/2006/main">
-            <a:r>
-              <a:t>- /Users/lilabrooks/Documents/aws-public-change-feed/docs/adr/024-isolated-live-runtime-exercises.md:10-15</a:t>
-            </a:r>
-          </a:p>
-          <a:p xmlns:a="http://schemas.openxmlformats.org/drawingml/2006/main">
-            <a:r>
-              <a:t>- /Users/lilabrooks/Documents/aws-public-change-feed/README.md:20-29</a:t>
+              <a:t>- /Users/lilabrooks/Documents/aws-public-change-feed/site/index.html</a:t>
+            </a:r>
+          </a:p>
+          <a:p xmlns:a="http://schemas.openxmlformats.org/drawingml/2006/main">
+            <a:r>
+              <a:t>- /Users/lilabrooks/Documents/aws-public-change-feed/docs/adr/024-isolated-live-runtime-exercises.md</a:t>
+            </a:r>
+          </a:p>
+          <a:p xmlns:a="http://schemas.openxmlformats.org/drawingml/2006/main">
+            <a:r>
+              <a:t>- /Users/lilabrooks/Documents/aws-public-change-feed/README.md</a:t>
             </a:r>
           </a:p>
         </p:txBody>
@@ -1220,7 +1220,7 @@
           <a:lstStyle xmlns:a="http://schemas.openxmlformats.org/drawingml/2006/main"/>
           <a:p xmlns:a="http://schemas.openxmlformats.org/drawingml/2006/main">
             <a:r>
-              <a:t>So, what closed the milestone? Four runtime triggers were enabled. Twelve public-feed posts reached Slack. Both recovery cases passed. The isolated load run created fifty messages at five per minute, and the alarm email arrived. That gives the dev MVP executable evidence. Production readiness stays a later gate.</a:t>
+              <a:t>So, what closed the milestone? Four runtime triggers were enabled. Twelve public-feed posts reached Slack. Both recovery cases passed. The isolated load run created fifty messages at five per minute, and the alarm email arrived. Those Slack, recovery, load, and alarm results close the dev MVP. Production readiness stays a later gate.</a:t>
             </a:r>
           </a:p>
           <a:p xmlns:a="http://schemas.openxmlformats.org/drawingml/2006/main">
@@ -1235,7 +1235,7 @@
           </a:p>
           <a:p xmlns:a="http://schemas.openxmlformats.org/drawingml/2006/main">
             <a:r>
-              <a:t>- /Users/lilabrooks/Documents/aws-public-change-feed/README.md:18-29</a:t>
+              <a:t>- /Users/lilabrooks/Documents/aws-public-change-feed/README.md</a:t>
             </a:r>
           </a:p>
           <a:p xmlns:a="http://schemas.openxmlformats.org/drawingml/2006/main">
@@ -1245,7 +1245,7 @@
           </a:p>
           <a:p xmlns:a="http://schemas.openxmlformats.org/drawingml/2006/main">
             <a:r>
-              <a:t>- /Users/lilabrooks/Documents/aws-public-change-feed/docs/architecture/specification/06-acceptance-and-generation.md:201-225</a:t>
+              <a:t>- /Users/lilabrooks/Documents/aws-public-change-feed/docs/architecture/specification/06-acceptance-and-generation.md</a:t>
             </a:r>
           </a:p>
         </p:txBody>
@@ -1313,7 +1313,7 @@
   </p:cSld>
   <p:clrMap bg1="lt1" tx1="dk1" bg2="lt2" tx2="dk2" accent1="accent1" accent2="accent2" accent3="accent3" accent4="accent4" accent5="accent5" accent6="accent6" hlink="hlink" folHlink="folHlink"/>
   <p:sldLayoutIdLst>
-    <p:sldLayoutId xmlns:r="http://schemas.openxmlformats.org/officeDocument/2006/relationships" id="2147483649" r:id="R62792ef662e34255"/>
+    <p:sldLayoutId xmlns:r="http://schemas.openxmlformats.org/officeDocument/2006/relationships" id="2147483649" r:id="Rb6cf7d8b5ff243f5"/>
   </p:sldLayoutIdLst>
   <p:txStyles>
     <p:titleStyle>
@@ -1905,7 +1905,7 @@
                   <a:srgbClr val="65B7FF"/>
                 </a:solidFill>
               </a:rPr>
-              <a:t>DEV MVP EVIDENCE</a:t>
+              <a:t>DEV MVP RESULTS</a:t>
             </a:r>
           </a:p>
         </p:txBody>
@@ -2025,7 +2025,7 @@
                   <a:srgbClr val="D3DEEA"/>
                 </a:solidFill>
               </a:rPr>
-              <a:t>Public AWS feeds become explainable, route-scoped review candidates and reach Slack through a durable AWS delivery path.</a:t>
+              <a:t>Public AWS announcements are matched against configured services and risk phrases, mapped to Slack routes, stored in DynamoDB, and delivered through SQS.</a:t>
             </a:r>
           </a:p>
         </p:txBody>
@@ -2107,7 +2107,7 @@
                   <a:srgbClr val="8EA0B8"/>
                 </a:solidFill>
               </a:rPr>
-              <a:t>EVIDENCE WINDOW</a:t>
+              <a:t>RECORDED RUN</a:t>
             </a:r>
           </a:p>
         </p:txBody>
@@ -2419,7 +2419,7 @@
                   <a:srgbClr val="8EA0B8"/>
                 </a:solidFill>
               </a:rPr>
-              <a:t>Repository evidence · public edition</a:t>
+              <a:t>Repository results · public edition</a:t>
             </a:r>
           </a:p>
         </p:txBody>
@@ -2701,11 +2701,11 @@
           <p:nvPr/>
         </p:nvPicPr>
         <p:blipFill>
-          <a:blip xmlns:r="http://schemas.openxmlformats.org/officeDocument/2006/relationships" xmlns:a="http://schemas.openxmlformats.org/drawingml/2006/main" r:embed="Rda1755c2387849b3"/>
+          <a:blip xmlns:r="http://schemas.openxmlformats.org/officeDocument/2006/relationships" xmlns:a="http://schemas.openxmlformats.org/drawingml/2006/main" r:embed="R9c1b77da01e3412c"/>
           <a:stretch xmlns:a="http://schemas.openxmlformats.org/drawingml/2006/main"/>
         </p:blipFill>
         <p:spPr>
-          <a:xfrm xmlns:a="http://schemas.openxmlformats.org/drawingml/2006/main">
+          <a:xfrm xmlns:a="http://schemas.openxmlformats.org/drawingml/2006/main" flipH="0" flipV="0">
             <a:off x="1128346" y="1466850"/>
             <a:ext cx="9935308" cy="4305300"/>
           </a:xfrm>
@@ -4192,7 +4192,7 @@
                   <a:srgbClr val="8EA0B8"/>
                 </a:solidFill>
               </a:rPr>
-              <a:t>TRIGGER PROOF</a:t>
+              <a:t>ENABLED TRIGGERS</a:t>
             </a:r>
           </a:p>
         </p:txBody>
@@ -4294,7 +4294,7 @@
                   <a:srgbClr val="8EA0B8"/>
                 </a:solidFill>
               </a:rPr>
-              <a:t>PACKAGE BOUNDARY</a:t>
+              <a:t>PACKAGE DIGEST</a:t>
             </a:r>
           </a:p>
         </p:txBody>
@@ -4345,7 +4345,7 @@
                   <a:srgbClr val="65B7FF"/>
                 </a:solidFill>
               </a:rPr>
-              <a:t>exact shared bytes</a:t>
+              <a:t>same SHA-256 digest</a:t>
             </a:r>
           </a:p>
         </p:txBody>
@@ -5363,7 +5363,7 @@
                   <a:srgbClr val="D3DEEA"/>
                 </a:solidFill>
               </a:rPr>
-              <a:t>Scoped concurrency evidence</a:t>
+              <a:t>Scoped S3 test identity</a:t>
             </a:r>
           </a:p>
         </p:txBody>
@@ -7969,7 +7969,7 @@
                   <a:srgbClr val="F5F8FC"/>
                 </a:solidFill>
               </a:rPr>
-              <a:t>4 of 10 service/risk pairs have only 1-2 positives. More historical examples are the next evidence need.</a:t>
+              <a:t>4 of 10 service/risk pairs have only 1–2 positives. More labeled historical examples are needed.</a:t>
             </a:r>
           </a:p>
         </p:txBody>
@@ -10121,7 +10121,7 @@
                   <a:srgbClr val="65B7FF"/>
                 </a:solidFill>
               </a:rPr>
-              <a:t>DURABLE DELIVERY</a:t>
+              <a:t>DELIVERY STATE</a:t>
             </a:r>
           </a:p>
         </p:txBody>
@@ -10904,7 +10904,7 @@
                   <a:srgbClr val="D3DEEA"/>
                 </a:solidFill>
               </a:rPr>
-              <a:t>documented success</a:t>
+              <a:t>Slack success response</a:t>
             </a:r>
           </a:p>
         </p:txBody>
@@ -11693,7 +11693,7 @@
                   <a:srgbClr val="65B7FF"/>
                 </a:solidFill>
               </a:rPr>
-              <a:t>DELIVERY EVIDENCE</a:t>
+              <a:t>RECORDED DELIVERY RESULT</a:t>
             </a:r>
           </a:p>
         </p:txBody>
@@ -11844,7 +11844,7 @@
           <p:nvPr/>
         </p:nvPicPr>
         <p:blipFill>
-          <a:blip xmlns:r="http://schemas.openxmlformats.org/officeDocument/2006/relationships" xmlns:a="http://schemas.openxmlformats.org/drawingml/2006/main" r:embed="Ra88c3f8db3994aa7"/>
+          <a:blip xmlns:r="http://schemas.openxmlformats.org/officeDocument/2006/relationships" xmlns:a="http://schemas.openxmlformats.org/drawingml/2006/main" r:embed="R243dbe0b60d34469"/>
           <a:stretch xmlns:a="http://schemas.openxmlformats.org/drawingml/2006/main"/>
         </p:blipFill>
         <p:spPr>
@@ -12007,7 +12007,7 @@
                   <a:srgbClr val="F5F8FC"/>
                 </a:solidFill>
               </a:rPr>
-              <a:t>durable Slack posts</a:t>
+              <a:t>recorded Slack posts</a:t>
             </a:r>
           </a:p>
         </p:txBody>
@@ -12404,7 +12404,7 @@
                   <a:srgbClr val="65B7FF"/>
                 </a:solidFill>
               </a:rPr>
-              <a:t>WHAT THE MVP PROVED</a:t>
+              <a:t>RECORDED MVP RESULT</a:t>
             </a:r>
           </a:p>
         </p:txBody>
@@ -12455,7 +12455,7 @@
                   <a:srgbClr val="F5F8FC"/>
                 </a:solidFill>
               </a:rPr>
-              <a:t>M1 closed on live delivery and operational evidence</a:t>
+              <a:t>M1 closed on Slack, recovery, load, and alarm results</a:t>
             </a:r>
           </a:p>
         </p:txBody>
@@ -13592,7 +13592,7 @@
                   <a:srgbClr val="8EA0B8"/>
                 </a:solidFill>
               </a:rPr>
-              <a:t>The dev MVP has executable evidence. Production readiness remains an explicit later decision.</a:t>
+              <a:t>The Slack, recovery, load, and alarm results close the dev MVP. Production readiness remains a later decision.</a:t>
             </a:r>
           </a:p>
         </p:txBody>

</xml_diff>